<commit_message>
Add lec3 and lec4
</commit_message>
<xml_diff>
--- a/Git-Lec-1-Lec2.pptx
+++ b/Git-Lec-1-Lec2.pptx
@@ -22,6 +22,28 @@
     <p:sldId id="270" r:id="rId17"/>
     <p:sldId id="271" r:id="rId18"/>
     <p:sldId id="272" r:id="rId19"/>
+    <p:sldId id="274" r:id="rId20"/>
+    <p:sldId id="273" r:id="rId21"/>
+    <p:sldId id="275" r:id="rId22"/>
+    <p:sldId id="276" r:id="rId23"/>
+    <p:sldId id="277" r:id="rId24"/>
+    <p:sldId id="278" r:id="rId25"/>
+    <p:sldId id="279" r:id="rId26"/>
+    <p:sldId id="280" r:id="rId27"/>
+    <p:sldId id="281" r:id="rId28"/>
+    <p:sldId id="282" r:id="rId29"/>
+    <p:sldId id="283" r:id="rId30"/>
+    <p:sldId id="284" r:id="rId31"/>
+    <p:sldId id="285" r:id="rId32"/>
+    <p:sldId id="286" r:id="rId33"/>
+    <p:sldId id="287" r:id="rId34"/>
+    <p:sldId id="288" r:id="rId35"/>
+    <p:sldId id="289" r:id="rId36"/>
+    <p:sldId id="290" r:id="rId37"/>
+    <p:sldId id="291" r:id="rId38"/>
+    <p:sldId id="292" r:id="rId39"/>
+    <p:sldId id="293" r:id="rId40"/>
+    <p:sldId id="294" r:id="rId41"/>
   </p:sldIdLst>
   <p:sldSz cx="12192000" cy="6858000"/>
   <p:notesSz cx="6858000" cy="9144000"/>
@@ -4451,6 +4473,348 @@
 </p:sld>
 </file>
 
+<file path=ppt/slides/slide18.xml><?xml version="1.0" encoding="utf-8"?>
+<p:sld xmlns:a="http://schemas.openxmlformats.org/drawingml/2006/main" xmlns:r="http://schemas.openxmlformats.org/officeDocument/2006/relationships" xmlns:p="http://schemas.openxmlformats.org/presentationml/2006/main">
+  <p:cSld>
+    <p:spTree>
+      <p:nvGrpSpPr>
+        <p:cNvPr id="1" name=""/>
+        <p:cNvGrpSpPr/>
+        <p:nvPr/>
+      </p:nvGrpSpPr>
+      <p:grpSpPr/>
+      <p:sp>
+        <p:nvSpPr>
+          <p:cNvPr id="2" name="Title 1"/>
+          <p:cNvSpPr>
+            <a:spLocks noGrp="1"/>
+          </p:cNvSpPr>
+          <p:nvPr>
+            <p:ph type="title"/>
+            <p:custDataLst>
+              <p:tags r:id="rId1"/>
+            </p:custDataLst>
+          </p:nvPr>
+        </p:nvSpPr>
+        <p:spPr/>
+        <p:txBody>
+          <a:bodyPr/>
+          <a:p>
+            <a:r>
+              <a:rPr lang="en-US" altLang="en-US"/>
+              <a:t>Simple Example</a:t>
+            </a:r>
+            <a:endParaRPr lang="en-US" altLang="en-US"/>
+          </a:p>
+        </p:txBody>
+      </p:sp>
+      <p:graphicFrame>
+        <p:nvGraphicFramePr>
+          <p:cNvPr id="4" name="Content Placeholder 3"/>
+          <p:cNvGraphicFramePr/>
+          <p:nvPr>
+            <p:ph idx="1"/>
+            <p:custDataLst>
+              <p:tags r:id="rId2"/>
+            </p:custDataLst>
+          </p:nvPr>
+        </p:nvGraphicFramePr>
+        <p:xfrm>
+          <a:off x="608400" y="1490400"/>
+          <a:ext cx="10968990" cy="381000"/>
+        </p:xfrm>
+        <a:graphic>
+          <a:graphicData uri="http://schemas.openxmlformats.org/drawingml/2006/table">
+            <a:tbl>
+              <a:tblPr firstRow="1" bandRow="1">
+                <a:tableStyleId>{5C22544A-7EE6-4342-B048-85BDC9FD1C3A}</a:tableStyleId>
+              </a:tblPr>
+              <a:tblGrid>
+                <a:gridCol w="10968990"/>
+              </a:tblGrid>
+              <a:tr h="381000">
+                <a:tc>
+                  <a:txBody>
+                    <a:bodyPr/>
+                    <a:p>
+                      <a:pPr>
+                        <a:buNone/>
+                      </a:pPr>
+                      <a:r>
+                        <a:rPr lang="en-US" altLang="en-US"/>
+                        <a:t>mkdir myproject</a:t>
+                      </a:r>
+                      <a:endParaRPr lang="en-US" altLang="en-US"/>
+                    </a:p>
+                    <a:p>
+                      <a:pPr>
+                        <a:buNone/>
+                      </a:pPr>
+                      <a:r>
+                        <a:rPr lang="en-US" altLang="en-US"/>
+                        <a:t>cd myproject</a:t>
+                      </a:r>
+                      <a:endParaRPr lang="en-US" altLang="en-US"/>
+                    </a:p>
+                    <a:p>
+                      <a:pPr>
+                        <a:buNone/>
+                      </a:pPr>
+                      <a:r>
+                        <a:rPr lang="en-US" altLang="en-US"/>
+                        <a:t>git init</a:t>
+                      </a:r>
+                      <a:endParaRPr lang="en-US" altLang="en-US"/>
+                    </a:p>
+                    <a:p>
+                      <a:pPr>
+                        <a:buNone/>
+                      </a:pPr>
+                      <a:endParaRPr lang="en-US" altLang="en-US"/>
+                    </a:p>
+                    <a:p>
+                      <a:pPr>
+                        <a:buNone/>
+                      </a:pPr>
+                      <a:r>
+                        <a:rPr lang="en-US" altLang="en-US"/>
+                        <a:t>echo "Hello world" &gt; intro.txt</a:t>
+                      </a:r>
+                      <a:endParaRPr lang="en-US" altLang="en-US"/>
+                    </a:p>
+                    <a:p>
+                      <a:pPr>
+                        <a:buNone/>
+                      </a:pPr>
+                      <a:r>
+                        <a:rPr lang="en-US" altLang="en-US"/>
+                        <a:t>git status</a:t>
+                      </a:r>
+                      <a:endParaRPr lang="en-US" altLang="en-US"/>
+                    </a:p>
+                    <a:p>
+                      <a:pPr>
+                        <a:buNone/>
+                      </a:pPr>
+                      <a:r>
+                        <a:rPr lang="en-US" altLang="en-US"/>
+                        <a:t>git add intro.txt</a:t>
+                      </a:r>
+                      <a:endParaRPr lang="en-US" altLang="en-US"/>
+                    </a:p>
+                    <a:p>
+                      <a:pPr>
+                        <a:buNone/>
+                      </a:pPr>
+                      <a:r>
+                        <a:rPr lang="en-US" altLang="en-US"/>
+                        <a:t>git commit -m "Initial commit"</a:t>
+                      </a:r>
+                      <a:endParaRPr lang="en-US" altLang="en-US"/>
+                    </a:p>
+                  </a:txBody>
+                  <a:tcPr>
+                    <a:solidFill>
+                      <a:schemeClr val="tx1"/>
+                    </a:solidFill>
+                  </a:tcPr>
+                </a:tc>
+              </a:tr>
+            </a:tbl>
+          </a:graphicData>
+        </a:graphic>
+      </p:graphicFrame>
+      <p:sp>
+        <p:nvSpPr>
+          <p:cNvPr id="6" name="Text Box 5"/>
+          <p:cNvSpPr txBox="1"/>
+          <p:nvPr/>
+        </p:nvSpPr>
+        <p:spPr>
+          <a:xfrm>
+            <a:off x="714375" y="4396740"/>
+            <a:ext cx="10862945" cy="368300"/>
+          </a:xfrm>
+          <a:prstGeom prst="rect">
+            <a:avLst/>
+          </a:prstGeom>
+        </p:spPr>
+        <p:txBody>
+          <a:bodyPr wrap="square">
+            <a:spAutoFit/>
+          </a:bodyPr>
+          <a:p>
+            <a:pPr marL="0" indent="0"/>
+            <a:r>
+              <a:rPr b="0" i="0">
+                <a:solidFill>
+                  <a:srgbClr val="1F2328"/>
+                </a:solidFill>
+                <a:latin typeface="Mona Sans VF"/>
+                <a:ea typeface="Mona Sans VF"/>
+              </a:rPr>
+              <a:t>This creates a Git repository, tracks a file, stages it, and saves it as a commit.</a:t>
+            </a:r>
+            <a:endParaRPr b="0" i="0">
+              <a:solidFill>
+                <a:srgbClr val="1F2328"/>
+              </a:solidFill>
+              <a:latin typeface="Mona Sans VF"/>
+              <a:ea typeface="Mona Sans VF"/>
+            </a:endParaRPr>
+          </a:p>
+        </p:txBody>
+      </p:sp>
+    </p:spTree>
+    <p:custDataLst>
+      <p:tags r:id="rId3"/>
+    </p:custDataLst>
+  </p:cSld>
+  <p:clrMapOvr>
+    <a:masterClrMapping/>
+  </p:clrMapOvr>
+</p:sld>
+</file>
+
+<file path=ppt/slides/slide19.xml><?xml version="1.0" encoding="utf-8"?>
+<p:sld xmlns:a="http://schemas.openxmlformats.org/drawingml/2006/main" xmlns:r="http://schemas.openxmlformats.org/officeDocument/2006/relationships" xmlns:p="http://schemas.openxmlformats.org/presentationml/2006/main">
+  <p:cSld>
+    <p:spTree>
+      <p:nvGrpSpPr>
+        <p:cNvPr id="1" name=""/>
+        <p:cNvGrpSpPr/>
+        <p:nvPr/>
+      </p:nvGrpSpPr>
+      <p:grpSpPr/>
+      <p:sp>
+        <p:nvSpPr>
+          <p:cNvPr id="2" name="Title 1"/>
+          <p:cNvSpPr>
+            <a:spLocks noGrp="1"/>
+          </p:cNvSpPr>
+          <p:nvPr>
+            <p:ph type="title"/>
+            <p:custDataLst>
+              <p:tags r:id="rId1"/>
+            </p:custDataLst>
+          </p:nvPr>
+        </p:nvSpPr>
+        <p:spPr/>
+        <p:txBody>
+          <a:bodyPr/>
+          <a:p>
+            <a:r>
+              <a:rPr lang="en-US" altLang="en-US"/>
+              <a:t>Beginner Tips</a:t>
+            </a:r>
+            <a:endParaRPr lang="en-US" altLang="en-US"/>
+          </a:p>
+        </p:txBody>
+      </p:sp>
+      <p:sp>
+        <p:nvSpPr>
+          <p:cNvPr id="3" name="Content Placeholder 2"/>
+          <p:cNvSpPr>
+            <a:spLocks noGrp="1"/>
+          </p:cNvSpPr>
+          <p:nvPr>
+            <p:ph idx="1"/>
+            <p:custDataLst>
+              <p:tags r:id="rId2"/>
+            </p:custDataLst>
+          </p:nvPr>
+        </p:nvSpPr>
+        <p:spPr/>
+        <p:txBody>
+          <a:bodyPr/>
+          <a:p>
+            <a:r>
+              <a:rPr lang="en-US" altLang="en-US">
+                <a:solidFill>
+                  <a:schemeClr val="tx1"/>
+                </a:solidFill>
+              </a:rPr>
+              <a:t>Commit often, but only after meaningful work</a:t>
+            </a:r>
+            <a:endParaRPr lang="en-US" altLang="en-US">
+              <a:solidFill>
+                <a:schemeClr val="tx1"/>
+              </a:solidFill>
+            </a:endParaRPr>
+          </a:p>
+          <a:p>
+            <a:r>
+              <a:rPr lang="en-US" altLang="en-US">
+                <a:solidFill>
+                  <a:schemeClr val="tx1"/>
+                </a:solidFill>
+              </a:rPr>
+              <a:t>Write clear commit messages</a:t>
+            </a:r>
+            <a:endParaRPr lang="en-US" altLang="en-US">
+              <a:solidFill>
+                <a:schemeClr val="tx1"/>
+              </a:solidFill>
+            </a:endParaRPr>
+          </a:p>
+          <a:p>
+            <a:r>
+              <a:rPr lang="en-US" altLang="en-US">
+                <a:solidFill>
+                  <a:schemeClr val="tx1"/>
+                </a:solidFill>
+              </a:rPr>
+              <a:t>Check git status before committing</a:t>
+            </a:r>
+            <a:endParaRPr lang="en-US" altLang="en-US">
+              <a:solidFill>
+                <a:schemeClr val="tx1"/>
+              </a:solidFill>
+            </a:endParaRPr>
+          </a:p>
+          <a:p>
+            <a:r>
+              <a:rPr lang="en-US" altLang="en-US">
+                <a:solidFill>
+                  <a:schemeClr val="tx1"/>
+                </a:solidFill>
+              </a:rPr>
+              <a:t>Do not stage everything unless you are sure</a:t>
+            </a:r>
+            <a:endParaRPr lang="en-US" altLang="en-US">
+              <a:solidFill>
+                <a:schemeClr val="tx1"/>
+              </a:solidFill>
+            </a:endParaRPr>
+          </a:p>
+          <a:p>
+            <a:r>
+              <a:rPr lang="en-US" altLang="en-US">
+                <a:solidFill>
+                  <a:schemeClr val="tx1"/>
+                </a:solidFill>
+              </a:rPr>
+              <a:t>Keep backups and use branches for risky changes</a:t>
+            </a:r>
+            <a:endParaRPr lang="en-US" altLang="en-US">
+              <a:solidFill>
+                <a:schemeClr val="tx1"/>
+              </a:solidFill>
+            </a:endParaRPr>
+          </a:p>
+        </p:txBody>
+      </p:sp>
+    </p:spTree>
+    <p:custDataLst>
+      <p:tags r:id="rId3"/>
+    </p:custDataLst>
+  </p:cSld>
+  <p:clrMapOvr>
+    <a:masterClrMapping/>
+  </p:clrMapOvr>
+</p:sld>
+</file>
+
 <file path=ppt/slides/slide2.xml><?xml version="1.0" encoding="utf-8"?>
 <p:sld xmlns:a="http://schemas.openxmlformats.org/drawingml/2006/main" xmlns:r="http://schemas.openxmlformats.org/officeDocument/2006/relationships" xmlns:p="http://schemas.openxmlformats.org/presentationml/2006/main">
   <p:cSld>
@@ -4631,6 +4995,1873 @@
 </p:sld>
 </file>
 
+<file path=ppt/slides/slide20.xml><?xml version="1.0" encoding="utf-8"?>
+<p:sld xmlns:a="http://schemas.openxmlformats.org/drawingml/2006/main" xmlns:r="http://schemas.openxmlformats.org/officeDocument/2006/relationships" xmlns:p="http://schemas.openxmlformats.org/presentationml/2006/main">
+  <p:cSld>
+    <p:spTree>
+      <p:nvGrpSpPr>
+        <p:cNvPr id="1" name=""/>
+        <p:cNvGrpSpPr/>
+        <p:nvPr/>
+      </p:nvGrpSpPr>
+      <p:grpSpPr/>
+      <p:sp>
+        <p:nvSpPr>
+          <p:cNvPr id="2" name="Title 1"/>
+          <p:cNvSpPr>
+            <a:spLocks noGrp="1"/>
+          </p:cNvSpPr>
+          <p:nvPr>
+            <p:ph type="title"/>
+            <p:custDataLst>
+              <p:tags r:id="rId1"/>
+            </p:custDataLst>
+          </p:nvPr>
+        </p:nvSpPr>
+        <p:spPr/>
+        <p:txBody>
+          <a:bodyPr/>
+          <a:p>
+            <a:r>
+              <a:rPr lang="en-US" altLang="en-US"/>
+              <a:t>Summary</a:t>
+            </a:r>
+            <a:endParaRPr lang="en-US" altLang="en-US"/>
+          </a:p>
+        </p:txBody>
+      </p:sp>
+      <p:sp>
+        <p:nvSpPr>
+          <p:cNvPr id="3" name="Content Placeholder 2"/>
+          <p:cNvSpPr>
+            <a:spLocks noGrp="1"/>
+          </p:cNvSpPr>
+          <p:nvPr>
+            <p:ph idx="1"/>
+            <p:custDataLst>
+              <p:tags r:id="rId2"/>
+            </p:custDataLst>
+          </p:nvPr>
+        </p:nvSpPr>
+        <p:spPr/>
+        <p:txBody>
+          <a:bodyPr/>
+          <a:p>
+            <a:pPr marL="0" indent="0">
+              <a:buNone/>
+            </a:pPr>
+            <a:r>
+              <a:rPr lang="en-US" altLang="en-US">
+                <a:solidFill>
+                  <a:schemeClr val="tx1"/>
+                </a:solidFill>
+              </a:rPr>
+              <a:t>We learned the basic idea of version control and how Git tracks project changes. The important concepts are:</a:t>
+            </a:r>
+            <a:endParaRPr lang="en-US" altLang="en-US">
+              <a:solidFill>
+                <a:schemeClr val="tx1"/>
+              </a:solidFill>
+            </a:endParaRPr>
+          </a:p>
+          <a:p>
+            <a:pPr marL="0" indent="0">
+              <a:buNone/>
+            </a:pPr>
+            <a:endParaRPr lang="en-US" altLang="en-US">
+              <a:solidFill>
+                <a:schemeClr val="tx1"/>
+              </a:solidFill>
+            </a:endParaRPr>
+          </a:p>
+          <a:p>
+            <a:r>
+              <a:rPr lang="en-US" altLang="en-US">
+                <a:solidFill>
+                  <a:schemeClr val="tx1"/>
+                </a:solidFill>
+              </a:rPr>
+              <a:t>Repository</a:t>
+            </a:r>
+            <a:endParaRPr lang="en-US" altLang="en-US">
+              <a:solidFill>
+                <a:schemeClr val="tx1"/>
+              </a:solidFill>
+            </a:endParaRPr>
+          </a:p>
+          <a:p>
+            <a:r>
+              <a:rPr lang="en-US" altLang="en-US">
+                <a:solidFill>
+                  <a:schemeClr val="tx1"/>
+                </a:solidFill>
+              </a:rPr>
+              <a:t>Working tree</a:t>
+            </a:r>
+            <a:endParaRPr lang="en-US" altLang="en-US">
+              <a:solidFill>
+                <a:schemeClr val="tx1"/>
+              </a:solidFill>
+            </a:endParaRPr>
+          </a:p>
+          <a:p>
+            <a:r>
+              <a:rPr lang="en-US" altLang="en-US">
+                <a:solidFill>
+                  <a:schemeClr val="tx1"/>
+                </a:solidFill>
+              </a:rPr>
+              <a:t>Staging area</a:t>
+            </a:r>
+            <a:endParaRPr lang="en-US" altLang="en-US">
+              <a:solidFill>
+                <a:schemeClr val="tx1"/>
+              </a:solidFill>
+            </a:endParaRPr>
+          </a:p>
+          <a:p>
+            <a:r>
+              <a:rPr lang="en-US" altLang="en-US">
+                <a:solidFill>
+                  <a:schemeClr val="tx1"/>
+                </a:solidFill>
+              </a:rPr>
+              <a:t>Commit</a:t>
+            </a:r>
+            <a:endParaRPr lang="en-US" altLang="en-US">
+              <a:solidFill>
+                <a:schemeClr val="tx1"/>
+              </a:solidFill>
+            </a:endParaRPr>
+          </a:p>
+          <a:p>
+            <a:r>
+              <a:rPr lang="en-US" altLang="en-US">
+                <a:solidFill>
+                  <a:schemeClr val="tx1"/>
+                </a:solidFill>
+              </a:rPr>
+              <a:t>Configuration</a:t>
+            </a:r>
+            <a:endParaRPr lang="en-US" altLang="en-US">
+              <a:solidFill>
+                <a:schemeClr val="tx1"/>
+              </a:solidFill>
+            </a:endParaRPr>
+          </a:p>
+          <a:p>
+            <a:r>
+              <a:rPr lang="en-US" altLang="en-US">
+                <a:solidFill>
+                  <a:schemeClr val="tx1"/>
+                </a:solidFill>
+              </a:rPr>
+              <a:t>Basic Git commands</a:t>
+            </a:r>
+            <a:endParaRPr lang="en-US" altLang="en-US">
+              <a:solidFill>
+                <a:schemeClr val="tx1"/>
+              </a:solidFill>
+            </a:endParaRPr>
+          </a:p>
+          <a:p>
+            <a:r>
+              <a:rPr lang="en-US" altLang="en-US">
+                <a:solidFill>
+                  <a:schemeClr val="tx1"/>
+                </a:solidFill>
+              </a:rPr>
+              <a:t>These are the foundations of using Git in real-world development.</a:t>
+            </a:r>
+            <a:endParaRPr lang="en-US" altLang="en-US">
+              <a:solidFill>
+                <a:schemeClr val="tx1"/>
+              </a:solidFill>
+            </a:endParaRPr>
+          </a:p>
+        </p:txBody>
+      </p:sp>
+    </p:spTree>
+    <p:custDataLst>
+      <p:tags r:id="rId3"/>
+    </p:custDataLst>
+  </p:cSld>
+  <p:clrMapOvr>
+    <a:masterClrMapping/>
+  </p:clrMapOvr>
+</p:sld>
+</file>
+
+<file path=ppt/slides/slide21.xml><?xml version="1.0" encoding="utf-8"?>
+<p:sld xmlns:a="http://schemas.openxmlformats.org/drawingml/2006/main" xmlns:r="http://schemas.openxmlformats.org/officeDocument/2006/relationships" xmlns:p="http://schemas.openxmlformats.org/presentationml/2006/main">
+  <p:cSld>
+    <p:spTree>
+      <p:nvGrpSpPr>
+        <p:cNvPr id="1" name=""/>
+        <p:cNvGrpSpPr/>
+        <p:nvPr/>
+      </p:nvGrpSpPr>
+      <p:grpSpPr/>
+      <p:sp>
+        <p:nvSpPr>
+          <p:cNvPr id="2" name="Title 1"/>
+          <p:cNvSpPr>
+            <a:spLocks noGrp="1"/>
+          </p:cNvSpPr>
+          <p:nvPr>
+            <p:ph type="title"/>
+            <p:custDataLst>
+              <p:tags r:id="rId1"/>
+            </p:custDataLst>
+          </p:nvPr>
+        </p:nvSpPr>
+        <p:spPr/>
+        <p:txBody>
+          <a:bodyPr/>
+          <a:p>
+            <a:r>
+              <a:rPr lang="en-US" altLang="en-US"/>
+              <a:t>1) Branching and Merging</a:t>
+            </a:r>
+            <a:endParaRPr lang="en-US" altLang="en-US"/>
+          </a:p>
+        </p:txBody>
+      </p:sp>
+      <p:sp>
+        <p:nvSpPr>
+          <p:cNvPr id="3" name="Content Placeholder 2"/>
+          <p:cNvSpPr>
+            <a:spLocks noGrp="1"/>
+          </p:cNvSpPr>
+          <p:nvPr>
+            <p:ph idx="1"/>
+            <p:custDataLst>
+              <p:tags r:id="rId2"/>
+            </p:custDataLst>
+          </p:nvPr>
+        </p:nvSpPr>
+        <p:spPr/>
+        <p:txBody>
+          <a:bodyPr/>
+          <a:p>
+            <a:pPr marL="0" indent="0">
+              <a:buNone/>
+            </a:pPr>
+            <a:r>
+              <a:rPr lang="en-US" altLang="en-US">
+                <a:solidFill>
+                  <a:schemeClr val="tx1"/>
+                </a:solidFill>
+              </a:rPr>
+              <a:t>A branch is a separate line of development inside the same repository.</a:t>
+            </a:r>
+            <a:endParaRPr lang="en-US" altLang="en-US">
+              <a:solidFill>
+                <a:schemeClr val="tx1"/>
+              </a:solidFill>
+            </a:endParaRPr>
+          </a:p>
+          <a:p>
+            <a:endParaRPr lang="en-US" altLang="en-US">
+              <a:solidFill>
+                <a:schemeClr val="tx1"/>
+              </a:solidFill>
+            </a:endParaRPr>
+          </a:p>
+          <a:p>
+            <a:pPr marL="0" indent="0">
+              <a:buNone/>
+            </a:pPr>
+            <a:r>
+              <a:rPr lang="en-US" altLang="en-US">
+                <a:solidFill>
+                  <a:schemeClr val="tx1"/>
+                </a:solidFill>
+              </a:rPr>
+              <a:t>Why use branches?</a:t>
+            </a:r>
+            <a:endParaRPr lang="en-US" altLang="en-US">
+              <a:solidFill>
+                <a:schemeClr val="tx1"/>
+              </a:solidFill>
+            </a:endParaRPr>
+          </a:p>
+          <a:p>
+            <a:endParaRPr lang="en-US" altLang="en-US">
+              <a:solidFill>
+                <a:schemeClr val="tx1"/>
+              </a:solidFill>
+            </a:endParaRPr>
+          </a:p>
+          <a:p>
+            <a:r>
+              <a:rPr lang="en-US" altLang="en-US">
+                <a:solidFill>
+                  <a:schemeClr val="tx1"/>
+                </a:solidFill>
+              </a:rPr>
+              <a:t>Work on new features without disturbing the main project</a:t>
+            </a:r>
+            <a:endParaRPr lang="en-US" altLang="en-US">
+              <a:solidFill>
+                <a:schemeClr val="tx1"/>
+              </a:solidFill>
+            </a:endParaRPr>
+          </a:p>
+          <a:p>
+            <a:r>
+              <a:rPr lang="en-US" altLang="en-US">
+                <a:solidFill>
+                  <a:schemeClr val="tx1"/>
+                </a:solidFill>
+              </a:rPr>
+              <a:t>Let multiple developers work independently</a:t>
+            </a:r>
+            <a:endParaRPr lang="en-US" altLang="en-US">
+              <a:solidFill>
+                <a:schemeClr val="tx1"/>
+              </a:solidFill>
+            </a:endParaRPr>
+          </a:p>
+          <a:p>
+            <a:r>
+              <a:rPr lang="en-US" altLang="en-US">
+                <a:solidFill>
+                  <a:schemeClr val="tx1"/>
+                </a:solidFill>
+              </a:rPr>
+              <a:t>Test changes before merging them into the main code</a:t>
+            </a:r>
+            <a:endParaRPr lang="en-US" altLang="en-US">
+              <a:solidFill>
+                <a:schemeClr val="tx1"/>
+              </a:solidFill>
+            </a:endParaRPr>
+          </a:p>
+        </p:txBody>
+      </p:sp>
+    </p:spTree>
+    <p:custDataLst>
+      <p:tags r:id="rId3"/>
+    </p:custDataLst>
+  </p:cSld>
+  <p:clrMapOvr>
+    <a:masterClrMapping/>
+  </p:clrMapOvr>
+</p:sld>
+</file>
+
+<file path=ppt/slides/slide22.xml><?xml version="1.0" encoding="utf-8"?>
+<p:sld xmlns:a="http://schemas.openxmlformats.org/drawingml/2006/main" xmlns:r="http://schemas.openxmlformats.org/officeDocument/2006/relationships" xmlns:p="http://schemas.openxmlformats.org/presentationml/2006/main">
+  <p:cSld>
+    <p:spTree>
+      <p:nvGrpSpPr>
+        <p:cNvPr id="1" name=""/>
+        <p:cNvGrpSpPr/>
+        <p:nvPr/>
+      </p:nvGrpSpPr>
+      <p:grpSpPr/>
+      <p:sp>
+        <p:nvSpPr>
+          <p:cNvPr id="2" name="Title 1"/>
+          <p:cNvSpPr>
+            <a:spLocks noGrp="1"/>
+          </p:cNvSpPr>
+          <p:nvPr>
+            <p:ph type="title"/>
+            <p:custDataLst>
+              <p:tags r:id="rId1"/>
+            </p:custDataLst>
+          </p:nvPr>
+        </p:nvSpPr>
+        <p:spPr/>
+        <p:txBody>
+          <a:bodyPr/>
+          <a:p>
+            <a:r>
+              <a:rPr lang="en-US" altLang="en-US"/>
+              <a:t>Example</a:t>
+            </a:r>
+            <a:endParaRPr lang="en-US" altLang="en-US"/>
+          </a:p>
+        </p:txBody>
+      </p:sp>
+      <p:graphicFrame>
+        <p:nvGraphicFramePr>
+          <p:cNvPr id="4" name="Content Placeholder 3"/>
+          <p:cNvGraphicFramePr/>
+          <p:nvPr>
+            <p:ph idx="1"/>
+            <p:custDataLst>
+              <p:tags r:id="rId2"/>
+            </p:custDataLst>
+          </p:nvPr>
+        </p:nvGraphicFramePr>
+        <p:xfrm>
+          <a:off x="608400" y="1490400"/>
+          <a:ext cx="10968990" cy="381000"/>
+        </p:xfrm>
+        <a:graphic>
+          <a:graphicData uri="http://schemas.openxmlformats.org/drawingml/2006/table">
+            <a:tbl>
+              <a:tblPr firstRow="1" bandRow="1">
+                <a:tableStyleId>{5C22544A-7EE6-4342-B048-85BDC9FD1C3A}</a:tableStyleId>
+              </a:tblPr>
+              <a:tblGrid>
+                <a:gridCol w="10968990"/>
+              </a:tblGrid>
+              <a:tr h="381000">
+                <a:tc>
+                  <a:txBody>
+                    <a:bodyPr/>
+                    <a:p>
+                      <a:pPr>
+                        <a:buNone/>
+                      </a:pPr>
+                      <a:r>
+                        <a:rPr lang="en-US" altLang="en-US"/>
+                        <a:t>git branch feature-login</a:t>
+                      </a:r>
+                      <a:endParaRPr lang="en-US" altLang="en-US"/>
+                    </a:p>
+                    <a:p>
+                      <a:pPr>
+                        <a:buNone/>
+                      </a:pPr>
+                      <a:r>
+                        <a:rPr lang="en-US" altLang="en-US"/>
+                        <a:t>git switch feature-login</a:t>
+                      </a:r>
+                      <a:endParaRPr lang="en-US" altLang="en-US"/>
+                    </a:p>
+                  </a:txBody>
+                  <a:tcPr>
+                    <a:solidFill>
+                      <a:schemeClr val="tx1"/>
+                    </a:solidFill>
+                  </a:tcPr>
+                </a:tc>
+              </a:tr>
+            </a:tbl>
+          </a:graphicData>
+        </a:graphic>
+      </p:graphicFrame>
+      <p:sp>
+        <p:nvSpPr>
+          <p:cNvPr id="5" name="Text Box 4"/>
+          <p:cNvSpPr txBox="1"/>
+          <p:nvPr/>
+        </p:nvSpPr>
+        <p:spPr>
+          <a:xfrm>
+            <a:off x="608330" y="2923540"/>
+            <a:ext cx="10968990" cy="460375"/>
+          </a:xfrm>
+          <a:prstGeom prst="rect">
+            <a:avLst/>
+          </a:prstGeom>
+        </p:spPr>
+        <p:txBody>
+          <a:bodyPr wrap="square">
+            <a:spAutoFit/>
+          </a:bodyPr>
+          <a:p>
+            <a:pPr marL="0" indent="0"/>
+            <a:r>
+              <a:rPr sz="2400" b="0" i="0">
+                <a:solidFill>
+                  <a:srgbClr val="1F2328"/>
+                </a:solidFill>
+                <a:latin typeface="Mona Sans VF"/>
+                <a:ea typeface="Mona Sans VF"/>
+              </a:rPr>
+              <a:t>This creates a new branch and moves you to it.</a:t>
+            </a:r>
+            <a:endParaRPr sz="2400" b="0" i="0">
+              <a:solidFill>
+                <a:srgbClr val="1F2328"/>
+              </a:solidFill>
+              <a:latin typeface="Mona Sans VF"/>
+              <a:ea typeface="Mona Sans VF"/>
+            </a:endParaRPr>
+          </a:p>
+        </p:txBody>
+      </p:sp>
+    </p:spTree>
+    <p:custDataLst>
+      <p:tags r:id="rId3"/>
+    </p:custDataLst>
+  </p:cSld>
+  <p:clrMapOvr>
+    <a:masterClrMapping/>
+  </p:clrMapOvr>
+</p:sld>
+</file>
+
+<file path=ppt/slides/slide23.xml><?xml version="1.0" encoding="utf-8"?>
+<p:sld xmlns:a="http://schemas.openxmlformats.org/drawingml/2006/main" xmlns:r="http://schemas.openxmlformats.org/officeDocument/2006/relationships" xmlns:p="http://schemas.openxmlformats.org/presentationml/2006/main">
+  <p:cSld>
+    <p:spTree>
+      <p:nvGrpSpPr>
+        <p:cNvPr id="1" name=""/>
+        <p:cNvGrpSpPr/>
+        <p:nvPr/>
+      </p:nvGrpSpPr>
+      <p:grpSpPr/>
+      <p:sp>
+        <p:nvSpPr>
+          <p:cNvPr id="2" name="Title 1"/>
+          <p:cNvSpPr>
+            <a:spLocks noGrp="1"/>
+          </p:cNvSpPr>
+          <p:nvPr>
+            <p:ph type="title"/>
+            <p:custDataLst>
+              <p:tags r:id="rId1"/>
+            </p:custDataLst>
+          </p:nvPr>
+        </p:nvSpPr>
+        <p:spPr/>
+        <p:txBody>
+          <a:bodyPr/>
+          <a:p>
+            <a:r>
+              <a:rPr lang="en-US" altLang="en-US"/>
+              <a:t>Merge</a:t>
+            </a:r>
+            <a:endParaRPr lang="en-US" altLang="en-US"/>
+          </a:p>
+        </p:txBody>
+      </p:sp>
+      <p:sp>
+        <p:nvSpPr>
+          <p:cNvPr id="3" name="Content Placeholder 2"/>
+          <p:cNvSpPr>
+            <a:spLocks noGrp="1"/>
+          </p:cNvSpPr>
+          <p:nvPr>
+            <p:ph idx="1"/>
+            <p:custDataLst>
+              <p:tags r:id="rId2"/>
+            </p:custDataLst>
+          </p:nvPr>
+        </p:nvSpPr>
+        <p:spPr/>
+        <p:txBody>
+          <a:bodyPr/>
+          <a:p>
+            <a:r>
+              <a:rPr lang="en-US" altLang="en-US">
+                <a:solidFill>
+                  <a:schemeClr val="tx1"/>
+                </a:solidFill>
+              </a:rPr>
+              <a:t>When the feature is finished, you merge it into the main branch.</a:t>
+            </a:r>
+            <a:endParaRPr lang="en-US" altLang="en-US">
+              <a:solidFill>
+                <a:schemeClr val="tx1"/>
+              </a:solidFill>
+            </a:endParaRPr>
+          </a:p>
+          <a:p>
+            <a:endParaRPr lang="en-US" altLang="en-US">
+              <a:solidFill>
+                <a:schemeClr val="tx1"/>
+              </a:solidFill>
+            </a:endParaRPr>
+          </a:p>
+          <a:p>
+            <a:endParaRPr lang="en-US" altLang="en-US">
+              <a:solidFill>
+                <a:schemeClr val="tx1"/>
+              </a:solidFill>
+            </a:endParaRPr>
+          </a:p>
+        </p:txBody>
+      </p:sp>
+      <p:graphicFrame>
+        <p:nvGraphicFramePr>
+          <p:cNvPr id="4" name="Table 3"/>
+          <p:cNvGraphicFramePr/>
+          <p:nvPr>
+            <p:custDataLst>
+              <p:tags r:id="rId3"/>
+            </p:custDataLst>
+          </p:nvPr>
+        </p:nvGraphicFramePr>
+        <p:xfrm>
+          <a:off x="608330" y="2183765"/>
+          <a:ext cx="10968990" cy="640080"/>
+        </p:xfrm>
+        <a:graphic>
+          <a:graphicData uri="http://schemas.openxmlformats.org/drawingml/2006/table">
+            <a:tbl>
+              <a:tblPr firstRow="1" bandRow="1">
+                <a:tableStyleId>{5C22544A-7EE6-4342-B048-85BDC9FD1C3A}</a:tableStyleId>
+              </a:tblPr>
+              <a:tblGrid>
+                <a:gridCol w="10968990"/>
+              </a:tblGrid>
+              <a:tr h="381000">
+                <a:tc>
+                  <a:txBody>
+                    <a:bodyPr/>
+                    <a:p>
+                      <a:pPr>
+                        <a:buNone/>
+                      </a:pPr>
+                      <a:r>
+                        <a:rPr lang="en-US" altLang="en-US"/>
+                        <a:t>git switch main</a:t>
+                      </a:r>
+                      <a:endParaRPr lang="en-US" altLang="en-US"/>
+                    </a:p>
+                    <a:p>
+                      <a:pPr>
+                        <a:buNone/>
+                      </a:pPr>
+                      <a:r>
+                        <a:rPr lang="en-US" altLang="en-US"/>
+                        <a:t>git merge feature-login</a:t>
+                      </a:r>
+                      <a:endParaRPr lang="en-US" altLang="en-US"/>
+                    </a:p>
+                  </a:txBody>
+                  <a:tcPr>
+                    <a:solidFill>
+                      <a:schemeClr val="tx1"/>
+                    </a:solidFill>
+                  </a:tcPr>
+                </a:tc>
+              </a:tr>
+            </a:tbl>
+          </a:graphicData>
+        </a:graphic>
+      </p:graphicFrame>
+      <p:sp>
+        <p:nvSpPr>
+          <p:cNvPr id="5" name="Text Box 4"/>
+          <p:cNvSpPr txBox="1"/>
+          <p:nvPr/>
+        </p:nvSpPr>
+        <p:spPr>
+          <a:xfrm>
+            <a:off x="612140" y="3429000"/>
+            <a:ext cx="11120755" cy="460375"/>
+          </a:xfrm>
+          <a:prstGeom prst="rect">
+            <a:avLst/>
+          </a:prstGeom>
+        </p:spPr>
+        <p:txBody>
+          <a:bodyPr wrap="square">
+            <a:spAutoFit/>
+          </a:bodyPr>
+          <a:p>
+            <a:pPr marL="0" indent="0"/>
+            <a:r>
+              <a:rPr sz="2400" b="0" i="0">
+                <a:solidFill>
+                  <a:srgbClr val="1F2328"/>
+                </a:solidFill>
+                <a:latin typeface="Mona Sans VF"/>
+                <a:ea typeface="Mona Sans VF"/>
+              </a:rPr>
+              <a:t>A merge combines the work from one branch into another.</a:t>
+            </a:r>
+            <a:endParaRPr sz="2400" b="0" i="0">
+              <a:solidFill>
+                <a:srgbClr val="1F2328"/>
+              </a:solidFill>
+              <a:latin typeface="Mona Sans VF"/>
+              <a:ea typeface="Mona Sans VF"/>
+            </a:endParaRPr>
+          </a:p>
+        </p:txBody>
+      </p:sp>
+    </p:spTree>
+    <p:custDataLst>
+      <p:tags r:id="rId4"/>
+    </p:custDataLst>
+  </p:cSld>
+  <p:clrMapOvr>
+    <a:masterClrMapping/>
+  </p:clrMapOvr>
+</p:sld>
+</file>
+
+<file path=ppt/slides/slide24.xml><?xml version="1.0" encoding="utf-8"?>
+<p:sld xmlns:a="http://schemas.openxmlformats.org/drawingml/2006/main" xmlns:r="http://schemas.openxmlformats.org/officeDocument/2006/relationships" xmlns:p="http://schemas.openxmlformats.org/presentationml/2006/main">
+  <p:cSld>
+    <p:spTree>
+      <p:nvGrpSpPr>
+        <p:cNvPr id="1" name=""/>
+        <p:cNvGrpSpPr/>
+        <p:nvPr/>
+      </p:nvGrpSpPr>
+      <p:grpSpPr/>
+      <p:sp>
+        <p:nvSpPr>
+          <p:cNvPr id="2" name="Title 1"/>
+          <p:cNvSpPr>
+            <a:spLocks noGrp="1"/>
+          </p:cNvSpPr>
+          <p:nvPr>
+            <p:ph type="title"/>
+            <p:custDataLst>
+              <p:tags r:id="rId1"/>
+            </p:custDataLst>
+          </p:nvPr>
+        </p:nvSpPr>
+        <p:spPr/>
+        <p:txBody>
+          <a:bodyPr/>
+          <a:p>
+            <a:r>
+              <a:rPr lang="en-US" altLang="en-US"/>
+              <a:t>Merge Conflicts</a:t>
+            </a:r>
+            <a:endParaRPr lang="en-US" altLang="en-US"/>
+          </a:p>
+        </p:txBody>
+      </p:sp>
+      <p:sp>
+        <p:nvSpPr>
+          <p:cNvPr id="3" name="Content Placeholder 2"/>
+          <p:cNvSpPr>
+            <a:spLocks noGrp="1"/>
+          </p:cNvSpPr>
+          <p:nvPr>
+            <p:ph idx="1"/>
+            <p:custDataLst>
+              <p:tags r:id="rId2"/>
+            </p:custDataLst>
+          </p:nvPr>
+        </p:nvSpPr>
+        <p:spPr/>
+        <p:txBody>
+          <a:bodyPr/>
+          <a:p>
+            <a:pPr marL="0" indent="0">
+              <a:buNone/>
+            </a:pPr>
+            <a:r>
+              <a:rPr lang="en-US" altLang="en-US">
+                <a:solidFill>
+                  <a:schemeClr val="tx1"/>
+                </a:solidFill>
+              </a:rPr>
+              <a:t>A merge conflict happens when Git cannot automatically decide how to combine changes from two branches.</a:t>
+            </a:r>
+            <a:endParaRPr lang="en-US" altLang="en-US">
+              <a:solidFill>
+                <a:schemeClr val="tx1"/>
+              </a:solidFill>
+            </a:endParaRPr>
+          </a:p>
+          <a:p>
+            <a:endParaRPr lang="en-US" altLang="en-US">
+              <a:solidFill>
+                <a:schemeClr val="tx1"/>
+              </a:solidFill>
+            </a:endParaRPr>
+          </a:p>
+          <a:p>
+            <a:pPr marL="0" indent="0">
+              <a:buNone/>
+            </a:pPr>
+            <a:r>
+              <a:rPr lang="en-US" altLang="en-US">
+                <a:solidFill>
+                  <a:schemeClr val="tx1"/>
+                </a:solidFill>
+              </a:rPr>
+              <a:t>Example:</a:t>
+            </a:r>
+            <a:endParaRPr lang="en-US" altLang="en-US">
+              <a:solidFill>
+                <a:schemeClr val="tx1"/>
+              </a:solidFill>
+            </a:endParaRPr>
+          </a:p>
+          <a:p>
+            <a:pPr marL="0" indent="0">
+              <a:buNone/>
+            </a:pPr>
+            <a:endParaRPr lang="en-US" altLang="en-US">
+              <a:solidFill>
+                <a:schemeClr val="tx1"/>
+              </a:solidFill>
+            </a:endParaRPr>
+          </a:p>
+          <a:p>
+            <a:pPr marL="0" indent="0">
+              <a:buNone/>
+            </a:pPr>
+            <a:r>
+              <a:rPr lang="en-US" altLang="en-US">
+                <a:solidFill>
+                  <a:schemeClr val="tx1"/>
+                </a:solidFill>
+              </a:rPr>
+              <a:t>Branch A changed a line in a file</a:t>
+            </a:r>
+            <a:endParaRPr lang="en-US" altLang="en-US">
+              <a:solidFill>
+                <a:schemeClr val="tx1"/>
+              </a:solidFill>
+            </a:endParaRPr>
+          </a:p>
+          <a:p>
+            <a:pPr marL="0" indent="0">
+              <a:buNone/>
+            </a:pPr>
+            <a:r>
+              <a:rPr lang="en-US" altLang="en-US">
+                <a:solidFill>
+                  <a:schemeClr val="tx1"/>
+                </a:solidFill>
+              </a:rPr>
+              <a:t>Branch B also changed the same line</a:t>
+            </a:r>
+            <a:endParaRPr lang="en-US" altLang="en-US">
+              <a:solidFill>
+                <a:schemeClr val="tx1"/>
+              </a:solidFill>
+            </a:endParaRPr>
+          </a:p>
+          <a:p>
+            <a:pPr marL="0" indent="0">
+              <a:buNone/>
+            </a:pPr>
+            <a:r>
+              <a:rPr lang="en-US" altLang="en-US">
+                <a:solidFill>
+                  <a:schemeClr val="tx1"/>
+                </a:solidFill>
+              </a:rPr>
+              <a:t>Git needs help to decide the final result</a:t>
+            </a:r>
+            <a:endParaRPr lang="en-US" altLang="en-US">
+              <a:solidFill>
+                <a:schemeClr val="tx1"/>
+              </a:solidFill>
+            </a:endParaRPr>
+          </a:p>
+        </p:txBody>
+      </p:sp>
+    </p:spTree>
+    <p:custDataLst>
+      <p:tags r:id="rId3"/>
+    </p:custDataLst>
+  </p:cSld>
+  <p:clrMapOvr>
+    <a:masterClrMapping/>
+  </p:clrMapOvr>
+</p:sld>
+</file>
+
+<file path=ppt/slides/slide25.xml><?xml version="1.0" encoding="utf-8"?>
+<p:sld xmlns:a="http://schemas.openxmlformats.org/drawingml/2006/main" xmlns:r="http://schemas.openxmlformats.org/officeDocument/2006/relationships" xmlns:p="http://schemas.openxmlformats.org/presentationml/2006/main">
+  <p:cSld>
+    <p:spTree>
+      <p:nvGrpSpPr>
+        <p:cNvPr id="1" name=""/>
+        <p:cNvGrpSpPr/>
+        <p:nvPr/>
+      </p:nvGrpSpPr>
+      <p:grpSpPr/>
+      <p:sp>
+        <p:nvSpPr>
+          <p:cNvPr id="2" name="Title 1"/>
+          <p:cNvSpPr>
+            <a:spLocks noGrp="1"/>
+          </p:cNvSpPr>
+          <p:nvPr>
+            <p:ph type="title"/>
+            <p:custDataLst>
+              <p:tags r:id="rId1"/>
+            </p:custDataLst>
+          </p:nvPr>
+        </p:nvSpPr>
+        <p:spPr/>
+        <p:txBody>
+          <a:bodyPr/>
+          <a:p>
+            <a:r>
+              <a:rPr lang="en-US" altLang="en-US"/>
+              <a:t>Conflict Example</a:t>
+            </a:r>
+            <a:endParaRPr lang="en-US" altLang="en-US"/>
+          </a:p>
+        </p:txBody>
+      </p:sp>
+      <p:sp>
+        <p:nvSpPr>
+          <p:cNvPr id="3" name="Content Placeholder 2"/>
+          <p:cNvSpPr>
+            <a:spLocks noGrp="1"/>
+          </p:cNvSpPr>
+          <p:nvPr>
+            <p:ph idx="1"/>
+            <p:custDataLst>
+              <p:tags r:id="rId2"/>
+            </p:custDataLst>
+          </p:nvPr>
+        </p:nvSpPr>
+        <p:spPr/>
+        <p:txBody>
+          <a:bodyPr>
+            <a:normAutofit lnSpcReduction="20000"/>
+          </a:bodyPr>
+          <a:p>
+            <a:pPr marL="0" indent="0">
+              <a:buNone/>
+            </a:pPr>
+            <a:r>
+              <a:rPr lang="en-US" altLang="en-US">
+                <a:solidFill>
+                  <a:schemeClr val="tx1"/>
+                </a:solidFill>
+              </a:rPr>
+              <a:t>&lt;&lt;&lt;&lt;&lt;&lt;&lt; HEAD</a:t>
+            </a:r>
+            <a:endParaRPr lang="en-US" altLang="en-US">
+              <a:solidFill>
+                <a:schemeClr val="tx1"/>
+              </a:solidFill>
+            </a:endParaRPr>
+          </a:p>
+          <a:p>
+            <a:pPr marL="0" indent="0">
+              <a:buNone/>
+            </a:pPr>
+            <a:r>
+              <a:rPr lang="en-US" altLang="en-US">
+                <a:solidFill>
+                  <a:schemeClr val="tx1"/>
+                </a:solidFill>
+              </a:rPr>
+              <a:t>print("Old code")</a:t>
+            </a:r>
+            <a:endParaRPr lang="en-US" altLang="en-US">
+              <a:solidFill>
+                <a:schemeClr val="tx1"/>
+              </a:solidFill>
+            </a:endParaRPr>
+          </a:p>
+          <a:p>
+            <a:pPr marL="0" indent="0">
+              <a:buNone/>
+            </a:pPr>
+            <a:r>
+              <a:rPr lang="en-US" altLang="en-US">
+                <a:solidFill>
+                  <a:schemeClr val="tx1"/>
+                </a:solidFill>
+              </a:rPr>
+              <a:t>=======</a:t>
+            </a:r>
+            <a:endParaRPr lang="en-US" altLang="en-US">
+              <a:solidFill>
+                <a:schemeClr val="tx1"/>
+              </a:solidFill>
+            </a:endParaRPr>
+          </a:p>
+          <a:p>
+            <a:pPr marL="0" indent="0">
+              <a:buNone/>
+            </a:pPr>
+            <a:r>
+              <a:rPr lang="en-US" altLang="en-US">
+                <a:solidFill>
+                  <a:schemeClr val="tx1"/>
+                </a:solidFill>
+              </a:rPr>
+              <a:t>print("New code")</a:t>
+            </a:r>
+            <a:endParaRPr lang="en-US" altLang="en-US">
+              <a:solidFill>
+                <a:schemeClr val="tx1"/>
+              </a:solidFill>
+            </a:endParaRPr>
+          </a:p>
+          <a:p>
+            <a:pPr marL="0" indent="0">
+              <a:buNone/>
+            </a:pPr>
+            <a:r>
+              <a:rPr lang="en-US" altLang="en-US">
+                <a:solidFill>
+                  <a:schemeClr val="tx1"/>
+                </a:solidFill>
+              </a:rPr>
+              <a:t>&gt;&gt;&gt;&gt;&gt;&gt;&gt; feature-login</a:t>
+            </a:r>
+            <a:endParaRPr lang="en-US" altLang="en-US">
+              <a:solidFill>
+                <a:schemeClr val="tx1"/>
+              </a:solidFill>
+            </a:endParaRPr>
+          </a:p>
+          <a:p>
+            <a:endParaRPr lang="en-US" altLang="en-US">
+              <a:solidFill>
+                <a:schemeClr val="tx1"/>
+              </a:solidFill>
+            </a:endParaRPr>
+          </a:p>
+          <a:p>
+            <a:pPr marL="0" indent="0">
+              <a:buNone/>
+            </a:pPr>
+            <a:r>
+              <a:rPr lang="en-US" altLang="en-US">
+                <a:solidFill>
+                  <a:schemeClr val="tx1"/>
+                </a:solidFill>
+              </a:rPr>
+              <a:t>This means:</a:t>
+            </a:r>
+            <a:endParaRPr lang="en-US" altLang="en-US">
+              <a:solidFill>
+                <a:schemeClr val="tx1"/>
+              </a:solidFill>
+            </a:endParaRPr>
+          </a:p>
+          <a:p>
+            <a:endParaRPr lang="en-US" altLang="en-US">
+              <a:solidFill>
+                <a:schemeClr val="tx1"/>
+              </a:solidFill>
+            </a:endParaRPr>
+          </a:p>
+          <a:p>
+            <a:pPr marL="0" indent="0">
+              <a:buNone/>
+            </a:pPr>
+            <a:r>
+              <a:rPr lang="en-US" altLang="en-US">
+                <a:solidFill>
+                  <a:schemeClr val="tx1"/>
+                </a:solidFill>
+              </a:rPr>
+              <a:t>&lt;&lt;&lt;&lt;&lt;&lt;&lt; HEAD = current branch version</a:t>
+            </a:r>
+            <a:endParaRPr lang="en-US" altLang="en-US">
+              <a:solidFill>
+                <a:schemeClr val="tx1"/>
+              </a:solidFill>
+            </a:endParaRPr>
+          </a:p>
+          <a:p>
+            <a:pPr marL="0" indent="0">
+              <a:buNone/>
+            </a:pPr>
+            <a:r>
+              <a:rPr lang="en-US" altLang="en-US">
+                <a:solidFill>
+                  <a:schemeClr val="tx1"/>
+                </a:solidFill>
+              </a:rPr>
+              <a:t>======= = incoming branch version</a:t>
+            </a:r>
+            <a:endParaRPr lang="en-US" altLang="en-US">
+              <a:solidFill>
+                <a:schemeClr val="tx1"/>
+              </a:solidFill>
+            </a:endParaRPr>
+          </a:p>
+          <a:p>
+            <a:pPr marL="0" indent="0">
+              <a:buNone/>
+            </a:pPr>
+            <a:r>
+              <a:rPr lang="en-US" altLang="en-US">
+                <a:solidFill>
+                  <a:schemeClr val="tx1"/>
+                </a:solidFill>
+              </a:rPr>
+              <a:t>&gt;&gt;&gt;&gt;&gt;&gt;&gt; feature-login = branch being merged in</a:t>
+            </a:r>
+            <a:endParaRPr lang="en-US" altLang="en-US">
+              <a:solidFill>
+                <a:schemeClr val="tx1"/>
+              </a:solidFill>
+            </a:endParaRPr>
+          </a:p>
+        </p:txBody>
+      </p:sp>
+    </p:spTree>
+    <p:custDataLst>
+      <p:tags r:id="rId3"/>
+    </p:custDataLst>
+  </p:cSld>
+  <p:clrMapOvr>
+    <a:masterClrMapping/>
+  </p:clrMapOvr>
+</p:sld>
+</file>
+
+<file path=ppt/slides/slide26.xml><?xml version="1.0" encoding="utf-8"?>
+<p:sld xmlns:a="http://schemas.openxmlformats.org/drawingml/2006/main" xmlns:r="http://schemas.openxmlformats.org/officeDocument/2006/relationships" xmlns:p="http://schemas.openxmlformats.org/presentationml/2006/main">
+  <p:cSld>
+    <p:spTree>
+      <p:nvGrpSpPr>
+        <p:cNvPr id="1" name=""/>
+        <p:cNvGrpSpPr/>
+        <p:nvPr/>
+      </p:nvGrpSpPr>
+      <p:grpSpPr/>
+      <p:sp>
+        <p:nvSpPr>
+          <p:cNvPr id="2" name="Title 1"/>
+          <p:cNvSpPr>
+            <a:spLocks noGrp="1"/>
+          </p:cNvSpPr>
+          <p:nvPr>
+            <p:ph type="title"/>
+            <p:custDataLst>
+              <p:tags r:id="rId1"/>
+            </p:custDataLst>
+          </p:nvPr>
+        </p:nvSpPr>
+        <p:spPr/>
+        <p:txBody>
+          <a:bodyPr/>
+          <a:p>
+            <a:r>
+              <a:rPr lang="en-US" altLang="en-US"/>
+              <a:t>Conflict Resolution</a:t>
+            </a:r>
+            <a:endParaRPr lang="en-US" altLang="en-US"/>
+          </a:p>
+        </p:txBody>
+      </p:sp>
+      <p:sp>
+        <p:nvSpPr>
+          <p:cNvPr id="3" name="Content Placeholder 2"/>
+          <p:cNvSpPr>
+            <a:spLocks noGrp="1"/>
+          </p:cNvSpPr>
+          <p:nvPr>
+            <p:ph idx="1"/>
+            <p:custDataLst>
+              <p:tags r:id="rId2"/>
+            </p:custDataLst>
+          </p:nvPr>
+        </p:nvSpPr>
+        <p:spPr/>
+        <p:txBody>
+          <a:bodyPr>
+            <a:normAutofit fontScale="90000" lnSpcReduction="20000"/>
+          </a:bodyPr>
+          <a:p>
+            <a:pPr marL="0" indent="0">
+              <a:buNone/>
+            </a:pPr>
+            <a:r>
+              <a:rPr lang="en-US" altLang="en-US">
+                <a:solidFill>
+                  <a:schemeClr val="tx1"/>
+                </a:solidFill>
+              </a:rPr>
+              <a:t>To resolve a conflict:</a:t>
+            </a:r>
+            <a:endParaRPr lang="en-US" altLang="en-US">
+              <a:solidFill>
+                <a:schemeClr val="tx1"/>
+              </a:solidFill>
+            </a:endParaRPr>
+          </a:p>
+          <a:p>
+            <a:endParaRPr lang="en-US" altLang="en-US">
+              <a:solidFill>
+                <a:schemeClr val="tx1"/>
+              </a:solidFill>
+            </a:endParaRPr>
+          </a:p>
+          <a:p>
+            <a:r>
+              <a:rPr lang="en-US" altLang="en-US">
+                <a:solidFill>
+                  <a:schemeClr val="tx1"/>
+                </a:solidFill>
+              </a:rPr>
+              <a:t>Open the conflicted file</a:t>
+            </a:r>
+            <a:endParaRPr lang="en-US" altLang="en-US">
+              <a:solidFill>
+                <a:schemeClr val="tx1"/>
+              </a:solidFill>
+            </a:endParaRPr>
+          </a:p>
+          <a:p>
+            <a:r>
+              <a:rPr lang="en-US" altLang="en-US">
+                <a:solidFill>
+                  <a:schemeClr val="tx1"/>
+                </a:solidFill>
+              </a:rPr>
+              <a:t>Read both versions</a:t>
+            </a:r>
+            <a:endParaRPr lang="en-US" altLang="en-US">
+              <a:solidFill>
+                <a:schemeClr val="tx1"/>
+              </a:solidFill>
+            </a:endParaRPr>
+          </a:p>
+          <a:p>
+            <a:r>
+              <a:rPr lang="en-US" altLang="en-US">
+                <a:solidFill>
+                  <a:schemeClr val="tx1"/>
+                </a:solidFill>
+              </a:rPr>
+              <a:t>Decide the correct final content</a:t>
+            </a:r>
+            <a:endParaRPr lang="en-US" altLang="en-US">
+              <a:solidFill>
+                <a:schemeClr val="tx1"/>
+              </a:solidFill>
+            </a:endParaRPr>
+          </a:p>
+          <a:p>
+            <a:r>
+              <a:rPr lang="en-US" altLang="en-US">
+                <a:solidFill>
+                  <a:schemeClr val="tx1"/>
+                </a:solidFill>
+              </a:rPr>
+              <a:t>Remove conflict markers</a:t>
+            </a:r>
+            <a:endParaRPr lang="en-US" altLang="en-US">
+              <a:solidFill>
+                <a:schemeClr val="tx1"/>
+              </a:solidFill>
+            </a:endParaRPr>
+          </a:p>
+          <a:p>
+            <a:r>
+              <a:rPr lang="en-US" altLang="en-US">
+                <a:solidFill>
+                  <a:schemeClr val="tx1"/>
+                </a:solidFill>
+              </a:rPr>
+              <a:t>Save the file</a:t>
+            </a:r>
+            <a:endParaRPr lang="en-US" altLang="en-US">
+              <a:solidFill>
+                <a:schemeClr val="tx1"/>
+              </a:solidFill>
+            </a:endParaRPr>
+          </a:p>
+          <a:p>
+            <a:r>
+              <a:rPr lang="en-US" altLang="en-US">
+                <a:solidFill>
+                  <a:schemeClr val="tx1"/>
+                </a:solidFill>
+              </a:rPr>
+              <a:t>Stage the resolved file</a:t>
+            </a:r>
+            <a:endParaRPr lang="en-US" altLang="en-US">
+              <a:solidFill>
+                <a:schemeClr val="tx1"/>
+              </a:solidFill>
+            </a:endParaRPr>
+          </a:p>
+          <a:p>
+            <a:r>
+              <a:rPr lang="en-US" altLang="en-US">
+                <a:solidFill>
+                  <a:schemeClr val="tx1"/>
+                </a:solidFill>
+              </a:rPr>
+              <a:t>Commit the result</a:t>
+            </a:r>
+            <a:endParaRPr lang="en-US" altLang="en-US">
+              <a:solidFill>
+                <a:schemeClr val="tx1"/>
+              </a:solidFill>
+            </a:endParaRPr>
+          </a:p>
+          <a:p>
+            <a:endParaRPr lang="en-US" altLang="en-US">
+              <a:solidFill>
+                <a:schemeClr val="tx1"/>
+              </a:solidFill>
+            </a:endParaRPr>
+          </a:p>
+          <a:p>
+            <a:pPr marL="0" indent="0">
+              <a:buNone/>
+            </a:pPr>
+            <a:r>
+              <a:rPr lang="en-US" altLang="en-US">
+                <a:solidFill>
+                  <a:schemeClr val="bg1"/>
+                </a:solidFill>
+                <a:highlight>
+                  <a:srgbClr val="000000"/>
+                </a:highlight>
+              </a:rPr>
+              <a:t>git add file_name</a:t>
+            </a:r>
+            <a:endParaRPr lang="en-US" altLang="en-US">
+              <a:solidFill>
+                <a:schemeClr val="tx1"/>
+              </a:solidFill>
+            </a:endParaRPr>
+          </a:p>
+          <a:p>
+            <a:r>
+              <a:rPr lang="en-US" altLang="en-US">
+                <a:solidFill>
+                  <a:schemeClr val="tx1"/>
+                </a:solidFill>
+              </a:rPr>
+              <a:t>git commit -m "Resolve merge conflict"</a:t>
+            </a:r>
+            <a:endParaRPr lang="en-US" altLang="en-US">
+              <a:solidFill>
+                <a:schemeClr val="tx1"/>
+              </a:solidFill>
+            </a:endParaRPr>
+          </a:p>
+        </p:txBody>
+      </p:sp>
+    </p:spTree>
+    <p:custDataLst>
+      <p:tags r:id="rId3"/>
+    </p:custDataLst>
+  </p:cSld>
+  <p:clrMapOvr>
+    <a:masterClrMapping/>
+  </p:clrMapOvr>
+</p:sld>
+</file>
+
+<file path=ppt/slides/slide27.xml><?xml version="1.0" encoding="utf-8"?>
+<p:sld xmlns:a="http://schemas.openxmlformats.org/drawingml/2006/main" xmlns:r="http://schemas.openxmlformats.org/officeDocument/2006/relationships" xmlns:p="http://schemas.openxmlformats.org/presentationml/2006/main">
+  <p:cSld>
+    <p:spTree>
+      <p:nvGrpSpPr>
+        <p:cNvPr id="1" name=""/>
+        <p:cNvGrpSpPr/>
+        <p:nvPr/>
+      </p:nvGrpSpPr>
+      <p:grpSpPr/>
+      <p:sp>
+        <p:nvSpPr>
+          <p:cNvPr id="2" name="Title 1"/>
+          <p:cNvSpPr>
+            <a:spLocks noGrp="1"/>
+          </p:cNvSpPr>
+          <p:nvPr>
+            <p:ph type="title"/>
+            <p:custDataLst>
+              <p:tags r:id="rId1"/>
+            </p:custDataLst>
+          </p:nvPr>
+        </p:nvSpPr>
+        <p:spPr/>
+        <p:txBody>
+          <a:bodyPr/>
+          <a:p>
+            <a:r>
+              <a:rPr lang="en-US" altLang="en-US"/>
+              <a:t>Git Rebase</a:t>
+            </a:r>
+            <a:endParaRPr lang="en-US" altLang="en-US"/>
+          </a:p>
+        </p:txBody>
+      </p:sp>
+      <p:sp>
+        <p:nvSpPr>
+          <p:cNvPr id="3" name="Content Placeholder 2"/>
+          <p:cNvSpPr>
+            <a:spLocks noGrp="1"/>
+          </p:cNvSpPr>
+          <p:nvPr>
+            <p:ph idx="1"/>
+            <p:custDataLst>
+              <p:tags r:id="rId2"/>
+            </p:custDataLst>
+          </p:nvPr>
+        </p:nvSpPr>
+        <p:spPr/>
+        <p:txBody>
+          <a:bodyPr/>
+          <a:p>
+            <a:r>
+              <a:rPr lang="en-US" altLang="en-US">
+                <a:solidFill>
+                  <a:schemeClr val="tx1"/>
+                </a:solidFill>
+              </a:rPr>
+              <a:t>Rebase is another way to integrate changes from one branch into another.</a:t>
+            </a:r>
+            <a:endParaRPr lang="en-US" altLang="en-US">
+              <a:solidFill>
+                <a:schemeClr val="tx1"/>
+              </a:solidFill>
+            </a:endParaRPr>
+          </a:p>
+          <a:p>
+            <a:r>
+              <a:rPr lang="en-US" altLang="en-US">
+                <a:solidFill>
+                  <a:schemeClr val="tx1"/>
+                </a:solidFill>
+              </a:rPr>
+              <a:t>Instead of merging, rebase moves your branch commits on top of another branch.</a:t>
+            </a:r>
+            <a:endParaRPr lang="en-US" altLang="en-US">
+              <a:solidFill>
+                <a:schemeClr val="tx1"/>
+              </a:solidFill>
+            </a:endParaRPr>
+          </a:p>
+          <a:p>
+            <a:endParaRPr lang="en-US" altLang="en-US">
+              <a:solidFill>
+                <a:schemeClr val="tx1"/>
+              </a:solidFill>
+            </a:endParaRPr>
+          </a:p>
+          <a:p>
+            <a:pPr marL="0" indent="0">
+              <a:buNone/>
+            </a:pPr>
+            <a:r>
+              <a:rPr lang="en-US" altLang="en-US">
+                <a:solidFill>
+                  <a:schemeClr val="tx1"/>
+                </a:solidFill>
+              </a:rPr>
+              <a:t>Example</a:t>
+            </a:r>
+            <a:endParaRPr lang="en-US" altLang="en-US">
+              <a:solidFill>
+                <a:schemeClr val="tx1"/>
+              </a:solidFill>
+            </a:endParaRPr>
+          </a:p>
+          <a:p>
+            <a:pPr marL="0" indent="0">
+              <a:buNone/>
+            </a:pPr>
+            <a:endParaRPr lang="en-US" altLang="en-US">
+              <a:solidFill>
+                <a:schemeClr val="tx1"/>
+              </a:solidFill>
+            </a:endParaRPr>
+          </a:p>
+        </p:txBody>
+      </p:sp>
+      <p:graphicFrame>
+        <p:nvGraphicFramePr>
+          <p:cNvPr id="4" name="Table 3"/>
+          <p:cNvGraphicFramePr/>
+          <p:nvPr/>
+        </p:nvGraphicFramePr>
+        <p:xfrm>
+          <a:off x="608330" y="3841750"/>
+          <a:ext cx="10808335" cy="467360"/>
+        </p:xfrm>
+        <a:graphic>
+          <a:graphicData uri="http://schemas.openxmlformats.org/drawingml/2006/table">
+            <a:tbl>
+              <a:tblPr firstRow="1" bandRow="1">
+                <a:tableStyleId>{5C22544A-7EE6-4342-B048-85BDC9FD1C3A}</a:tableStyleId>
+              </a:tblPr>
+              <a:tblGrid>
+                <a:gridCol w="10808335"/>
+              </a:tblGrid>
+              <a:tr h="467360">
+                <a:tc>
+                  <a:txBody>
+                    <a:bodyPr/>
+                    <a:p>
+                      <a:pPr>
+                        <a:buNone/>
+                      </a:pPr>
+                      <a:r>
+                        <a:rPr lang="en-US" altLang="en-US"/>
+                        <a:t>git switch feature-login</a:t>
+                      </a:r>
+                      <a:endParaRPr lang="en-US" altLang="en-US"/>
+                    </a:p>
+                    <a:p>
+                      <a:pPr>
+                        <a:buNone/>
+                      </a:pPr>
+                      <a:r>
+                        <a:rPr lang="en-US" altLang="en-US"/>
+                        <a:t>git rebase main</a:t>
+                      </a:r>
+                      <a:endParaRPr lang="en-US" altLang="en-US"/>
+                    </a:p>
+                  </a:txBody>
+                  <a:tcPr>
+                    <a:solidFill>
+                      <a:schemeClr val="tx1"/>
+                    </a:solidFill>
+                  </a:tcPr>
+                </a:tc>
+              </a:tr>
+            </a:tbl>
+          </a:graphicData>
+        </a:graphic>
+      </p:graphicFrame>
+    </p:spTree>
+    <p:custDataLst>
+      <p:tags r:id="rId3"/>
+    </p:custDataLst>
+  </p:cSld>
+  <p:clrMapOvr>
+    <a:masterClrMapping/>
+  </p:clrMapOvr>
+</p:sld>
+</file>
+
+<file path=ppt/slides/slide28.xml><?xml version="1.0" encoding="utf-8"?>
+<p:sld xmlns:a="http://schemas.openxmlformats.org/drawingml/2006/main" xmlns:r="http://schemas.openxmlformats.org/officeDocument/2006/relationships" xmlns:p="http://schemas.openxmlformats.org/presentationml/2006/main">
+  <p:cSld>
+    <p:spTree>
+      <p:nvGrpSpPr>
+        <p:cNvPr id="1" name=""/>
+        <p:cNvGrpSpPr/>
+        <p:nvPr/>
+      </p:nvGrpSpPr>
+      <p:grpSpPr/>
+      <p:sp>
+        <p:nvSpPr>
+          <p:cNvPr id="2" name="Title 1"/>
+          <p:cNvSpPr>
+            <a:spLocks noGrp="1"/>
+          </p:cNvSpPr>
+          <p:nvPr>
+            <p:ph type="title"/>
+            <p:custDataLst>
+              <p:tags r:id="rId1"/>
+            </p:custDataLst>
+          </p:nvPr>
+        </p:nvSpPr>
+        <p:spPr/>
+        <p:txBody>
+          <a:bodyPr/>
+          <a:p>
+            <a:r>
+              <a:rPr lang="en-US" altLang="en-US"/>
+              <a:t>Rebase vs Merge</a:t>
+            </a:r>
+            <a:endParaRPr lang="en-US" altLang="en-US"/>
+          </a:p>
+        </p:txBody>
+      </p:sp>
+      <p:sp>
+        <p:nvSpPr>
+          <p:cNvPr id="3" name="Content Placeholder 2"/>
+          <p:cNvSpPr>
+            <a:spLocks noGrp="1"/>
+          </p:cNvSpPr>
+          <p:nvPr>
+            <p:ph idx="1"/>
+            <p:custDataLst>
+              <p:tags r:id="rId2"/>
+            </p:custDataLst>
+          </p:nvPr>
+        </p:nvSpPr>
+        <p:spPr/>
+        <p:txBody>
+          <a:bodyPr/>
+          <a:p>
+            <a:pPr marL="0" indent="0">
+              <a:buNone/>
+            </a:pPr>
+            <a:r>
+              <a:rPr lang="en-US" altLang="en-US">
+                <a:solidFill>
+                  <a:schemeClr val="tx1"/>
+                </a:solidFill>
+              </a:rPr>
+              <a:t>Merge keeps branch history and creates a merge commit</a:t>
+            </a:r>
+            <a:endParaRPr lang="en-US" altLang="en-US">
+              <a:solidFill>
+                <a:schemeClr val="tx1"/>
+              </a:solidFill>
+            </a:endParaRPr>
+          </a:p>
+          <a:p>
+            <a:r>
+              <a:rPr lang="en-US" altLang="en-US">
+                <a:solidFill>
+                  <a:schemeClr val="tx1"/>
+                </a:solidFill>
+              </a:rPr>
+              <a:t>Rebase creates a cleaner linear history</a:t>
+            </a:r>
+            <a:endParaRPr lang="en-US" altLang="en-US">
+              <a:solidFill>
+                <a:schemeClr val="tx1"/>
+              </a:solidFill>
+            </a:endParaRPr>
+          </a:p>
+          <a:p>
+            <a:r>
+              <a:rPr lang="en-US" altLang="en-US">
+                <a:solidFill>
+                  <a:schemeClr val="tx1"/>
+                </a:solidFill>
+              </a:rPr>
+              <a:t>Rebase can be useful, but it may be confusing for beginners and can rewrite commit history.</a:t>
+            </a:r>
+            <a:endParaRPr lang="en-US" altLang="en-US">
+              <a:solidFill>
+                <a:schemeClr val="tx1"/>
+              </a:solidFill>
+            </a:endParaRPr>
+          </a:p>
+        </p:txBody>
+      </p:sp>
+    </p:spTree>
+    <p:custDataLst>
+      <p:tags r:id="rId3"/>
+    </p:custDataLst>
+  </p:cSld>
+  <p:clrMapOvr>
+    <a:masterClrMapping/>
+  </p:clrMapOvr>
+</p:sld>
+</file>
+
+<file path=ppt/slides/slide29.xml><?xml version="1.0" encoding="utf-8"?>
+<p:sld xmlns:a="http://schemas.openxmlformats.org/drawingml/2006/main" xmlns:r="http://schemas.openxmlformats.org/officeDocument/2006/relationships" xmlns:p="http://schemas.openxmlformats.org/presentationml/2006/main">
+  <p:cSld>
+    <p:spTree>
+      <p:nvGrpSpPr>
+        <p:cNvPr id="1" name=""/>
+        <p:cNvGrpSpPr/>
+        <p:nvPr/>
+      </p:nvGrpSpPr>
+      <p:grpSpPr/>
+      <p:sp>
+        <p:nvSpPr>
+          <p:cNvPr id="2" name="Title 1"/>
+          <p:cNvSpPr>
+            <a:spLocks noGrp="1"/>
+          </p:cNvSpPr>
+          <p:nvPr>
+            <p:ph type="title"/>
+            <p:custDataLst>
+              <p:tags r:id="rId1"/>
+            </p:custDataLst>
+          </p:nvPr>
+        </p:nvSpPr>
+        <p:spPr/>
+        <p:txBody>
+          <a:bodyPr/>
+          <a:p>
+            <a:r>
+              <a:rPr lang="en-US" altLang="en-US"/>
+              <a:t>Tags</a:t>
+            </a:r>
+            <a:endParaRPr lang="en-US" altLang="en-US"/>
+          </a:p>
+        </p:txBody>
+      </p:sp>
+      <p:sp>
+        <p:nvSpPr>
+          <p:cNvPr id="3" name="Content Placeholder 2"/>
+          <p:cNvSpPr>
+            <a:spLocks noGrp="1"/>
+          </p:cNvSpPr>
+          <p:nvPr>
+            <p:ph idx="1"/>
+            <p:custDataLst>
+              <p:tags r:id="rId2"/>
+            </p:custDataLst>
+          </p:nvPr>
+        </p:nvSpPr>
+        <p:spPr/>
+        <p:txBody>
+          <a:bodyPr>
+            <a:normAutofit fontScale="90000" lnSpcReduction="20000"/>
+          </a:bodyPr>
+          <a:p>
+            <a:pPr marL="0" indent="0">
+              <a:buNone/>
+            </a:pPr>
+            <a:r>
+              <a:rPr lang="en-US" altLang="en-US">
+                <a:solidFill>
+                  <a:schemeClr val="tx1"/>
+                </a:solidFill>
+              </a:rPr>
+              <a:t>A tag marks an important point in the project, like a release version.</a:t>
+            </a:r>
+            <a:endParaRPr lang="en-US" altLang="en-US">
+              <a:solidFill>
+                <a:schemeClr val="tx1"/>
+              </a:solidFill>
+            </a:endParaRPr>
+          </a:p>
+          <a:p>
+            <a:endParaRPr lang="en-US" altLang="en-US">
+              <a:solidFill>
+                <a:schemeClr val="tx1"/>
+              </a:solidFill>
+            </a:endParaRPr>
+          </a:p>
+          <a:p>
+            <a:pPr marL="0" indent="0">
+              <a:buNone/>
+            </a:pPr>
+            <a:r>
+              <a:rPr lang="en-US" altLang="en-US">
+                <a:solidFill>
+                  <a:schemeClr val="tx1"/>
+                </a:solidFill>
+              </a:rPr>
+              <a:t>Example:</a:t>
+            </a:r>
+            <a:endParaRPr lang="en-US" altLang="en-US">
+              <a:solidFill>
+                <a:schemeClr val="tx1"/>
+              </a:solidFill>
+            </a:endParaRPr>
+          </a:p>
+          <a:p>
+            <a:endParaRPr lang="en-US" altLang="en-US">
+              <a:solidFill>
+                <a:schemeClr val="tx1"/>
+              </a:solidFill>
+            </a:endParaRPr>
+          </a:p>
+          <a:p>
+            <a:r>
+              <a:rPr lang="en-US" altLang="en-US">
+                <a:solidFill>
+                  <a:schemeClr val="tx1"/>
+                </a:solidFill>
+              </a:rPr>
+              <a:t>git tag v1.0</a:t>
+            </a:r>
+            <a:endParaRPr lang="en-US" altLang="en-US">
+              <a:solidFill>
+                <a:schemeClr val="tx1"/>
+              </a:solidFill>
+            </a:endParaRPr>
+          </a:p>
+          <a:p>
+            <a:r>
+              <a:rPr lang="en-US" altLang="en-US">
+                <a:solidFill>
+                  <a:schemeClr val="tx1"/>
+                </a:solidFill>
+              </a:rPr>
+              <a:t>git tag</a:t>
+            </a:r>
+            <a:endParaRPr lang="en-US" altLang="en-US">
+              <a:solidFill>
+                <a:schemeClr val="tx1"/>
+              </a:solidFill>
+            </a:endParaRPr>
+          </a:p>
+          <a:p>
+            <a:endParaRPr lang="en-US" altLang="en-US">
+              <a:solidFill>
+                <a:schemeClr val="tx1"/>
+              </a:solidFill>
+            </a:endParaRPr>
+          </a:p>
+          <a:p>
+            <a:pPr marL="0" indent="0">
+              <a:buNone/>
+            </a:pPr>
+            <a:r>
+              <a:rPr lang="en-US" altLang="en-US">
+                <a:solidFill>
+                  <a:schemeClr val="tx1"/>
+                </a:solidFill>
+              </a:rPr>
+              <a:t>Tags are useful for marking:</a:t>
+            </a:r>
+            <a:endParaRPr lang="en-US" altLang="en-US">
+              <a:solidFill>
+                <a:schemeClr val="tx1"/>
+              </a:solidFill>
+            </a:endParaRPr>
+          </a:p>
+          <a:p>
+            <a:endParaRPr lang="en-US" altLang="en-US">
+              <a:solidFill>
+                <a:schemeClr val="tx1"/>
+              </a:solidFill>
+            </a:endParaRPr>
+          </a:p>
+          <a:p>
+            <a:r>
+              <a:rPr lang="en-US" altLang="en-US">
+                <a:solidFill>
+                  <a:schemeClr val="tx1"/>
+                </a:solidFill>
+              </a:rPr>
+              <a:t>Release versions</a:t>
+            </a:r>
+            <a:endParaRPr lang="en-US" altLang="en-US">
+              <a:solidFill>
+                <a:schemeClr val="tx1"/>
+              </a:solidFill>
+            </a:endParaRPr>
+          </a:p>
+          <a:p>
+            <a:r>
+              <a:rPr lang="en-US" altLang="en-US">
+                <a:solidFill>
+                  <a:schemeClr val="tx1"/>
+                </a:solidFill>
+              </a:rPr>
+              <a:t>Stable checkpoints</a:t>
+            </a:r>
+            <a:endParaRPr lang="en-US" altLang="en-US">
+              <a:solidFill>
+                <a:schemeClr val="tx1"/>
+              </a:solidFill>
+            </a:endParaRPr>
+          </a:p>
+          <a:p>
+            <a:r>
+              <a:rPr lang="en-US" altLang="en-US">
+                <a:solidFill>
+                  <a:schemeClr val="tx1"/>
+                </a:solidFill>
+              </a:rPr>
+              <a:t>Production milestones</a:t>
+            </a:r>
+            <a:endParaRPr lang="en-US" altLang="en-US">
+              <a:solidFill>
+                <a:schemeClr val="tx1"/>
+              </a:solidFill>
+            </a:endParaRPr>
+          </a:p>
+        </p:txBody>
+      </p:sp>
+    </p:spTree>
+    <p:custDataLst>
+      <p:tags r:id="rId3"/>
+    </p:custDataLst>
+  </p:cSld>
+  <p:clrMapOvr>
+    <a:masterClrMapping/>
+  </p:clrMapOvr>
+</p:sld>
+</file>
+
 <file path=ppt/slides/slide3.xml><?xml version="1.0" encoding="utf-8"?>
 <p:sld xmlns:a="http://schemas.openxmlformats.org/drawingml/2006/main" xmlns:r="http://schemas.openxmlformats.org/officeDocument/2006/relationships" xmlns:p="http://schemas.openxmlformats.org/presentationml/2006/main">
   <p:cSld>
@@ -4775,6 +7006,1807 @@
                 </a:solidFill>
               </a:rPr>
               <a:t>Supported by platforms like GitHub and GitLab</a:t>
+            </a:r>
+            <a:endParaRPr lang="en-US" altLang="en-US">
+              <a:solidFill>
+                <a:schemeClr val="tx1"/>
+              </a:solidFill>
+            </a:endParaRPr>
+          </a:p>
+        </p:txBody>
+      </p:sp>
+    </p:spTree>
+    <p:custDataLst>
+      <p:tags r:id="rId3"/>
+    </p:custDataLst>
+  </p:cSld>
+  <p:clrMapOvr>
+    <a:masterClrMapping/>
+  </p:clrMapOvr>
+</p:sld>
+</file>
+
+<file path=ppt/slides/slide30.xml><?xml version="1.0" encoding="utf-8"?>
+<p:sld xmlns:a="http://schemas.openxmlformats.org/drawingml/2006/main" xmlns:r="http://schemas.openxmlformats.org/officeDocument/2006/relationships" xmlns:p="http://schemas.openxmlformats.org/presentationml/2006/main">
+  <p:cSld>
+    <p:spTree>
+      <p:nvGrpSpPr>
+        <p:cNvPr id="1" name=""/>
+        <p:cNvGrpSpPr/>
+        <p:nvPr/>
+      </p:nvGrpSpPr>
+      <p:grpSpPr/>
+      <p:sp>
+        <p:nvSpPr>
+          <p:cNvPr id="2" name="Title 1"/>
+          <p:cNvSpPr>
+            <a:spLocks noGrp="1"/>
+          </p:cNvSpPr>
+          <p:nvPr>
+            <p:ph type="title"/>
+            <p:custDataLst>
+              <p:tags r:id="rId1"/>
+            </p:custDataLst>
+          </p:nvPr>
+        </p:nvSpPr>
+        <p:spPr/>
+        <p:txBody>
+          <a:bodyPr>
+            <a:noAutofit/>
+          </a:bodyPr>
+          <a:p>
+            <a:r>
+              <a:rPr lang="en-US" altLang="en-US" sz="4000"/>
+              <a:t>Releases</a:t>
+            </a:r>
+            <a:endParaRPr lang="en-US" altLang="en-US" sz="4000"/>
+          </a:p>
+        </p:txBody>
+      </p:sp>
+      <p:sp>
+        <p:nvSpPr>
+          <p:cNvPr id="3" name="Content Placeholder 2"/>
+          <p:cNvSpPr>
+            <a:spLocks noGrp="1"/>
+          </p:cNvSpPr>
+          <p:nvPr>
+            <p:ph idx="1"/>
+            <p:custDataLst>
+              <p:tags r:id="rId2"/>
+            </p:custDataLst>
+          </p:nvPr>
+        </p:nvSpPr>
+        <p:spPr>
+          <a:xfrm>
+            <a:off x="608330" y="1313180"/>
+            <a:ext cx="10968990" cy="4936490"/>
+          </a:xfrm>
+        </p:spPr>
+        <p:txBody>
+          <a:bodyPr>
+            <a:noAutofit/>
+          </a:bodyPr>
+          <a:p>
+            <a:pPr marL="0" indent="0">
+              <a:buNone/>
+            </a:pPr>
+            <a:r>
+              <a:rPr lang="en-US" altLang="en-US" sz="1600">
+                <a:solidFill>
+                  <a:schemeClr val="tx1"/>
+                </a:solidFill>
+              </a:rPr>
+              <a:t>A release is a version of software that is ready for users or customers. Common release steps are</a:t>
+            </a:r>
+            <a:endParaRPr lang="en-US" altLang="en-US" sz="1600">
+              <a:solidFill>
+                <a:schemeClr val="tx1"/>
+              </a:solidFill>
+            </a:endParaRPr>
+          </a:p>
+          <a:p>
+            <a:r>
+              <a:rPr lang="en-US" altLang="en-US" sz="1600">
+                <a:solidFill>
+                  <a:schemeClr val="tx1"/>
+                </a:solidFill>
+              </a:rPr>
+              <a:t>Finish a stable version</a:t>
+            </a:r>
+            <a:endParaRPr lang="en-US" altLang="en-US" sz="1600">
+              <a:solidFill>
+                <a:schemeClr val="tx1"/>
+              </a:solidFill>
+            </a:endParaRPr>
+          </a:p>
+          <a:p>
+            <a:r>
+              <a:rPr lang="en-US" altLang="en-US" sz="1600">
+                <a:solidFill>
+                  <a:schemeClr val="tx1"/>
+                </a:solidFill>
+              </a:rPr>
+              <a:t>Test it</a:t>
+            </a:r>
+            <a:endParaRPr lang="en-US" altLang="en-US" sz="1600">
+              <a:solidFill>
+                <a:schemeClr val="tx1"/>
+              </a:solidFill>
+            </a:endParaRPr>
+          </a:p>
+          <a:p>
+            <a:r>
+              <a:rPr lang="en-US" altLang="en-US" sz="1600">
+                <a:solidFill>
+                  <a:schemeClr val="tx1"/>
+                </a:solidFill>
+              </a:rPr>
+              <a:t>Tag it with a version number</a:t>
+            </a:r>
+            <a:endParaRPr lang="en-US" altLang="en-US" sz="1600">
+              <a:solidFill>
+                <a:schemeClr val="tx1"/>
+              </a:solidFill>
+            </a:endParaRPr>
+          </a:p>
+          <a:p>
+            <a:r>
+              <a:rPr lang="en-US" altLang="en-US" sz="1600">
+                <a:solidFill>
+                  <a:schemeClr val="tx1"/>
+                </a:solidFill>
+              </a:rPr>
+              <a:t>Publish it</a:t>
+            </a:r>
+            <a:endParaRPr lang="en-US" altLang="en-US" sz="1600">
+              <a:solidFill>
+                <a:schemeClr val="tx1"/>
+              </a:solidFill>
+            </a:endParaRPr>
+          </a:p>
+          <a:p>
+            <a:r>
+              <a:rPr lang="en-US" altLang="en-US" sz="1600">
+                <a:solidFill>
+                  <a:schemeClr val="tx1"/>
+                </a:solidFill>
+              </a:rPr>
+              <a:t>Share changelog notes</a:t>
+            </a:r>
+            <a:endParaRPr lang="en-US" altLang="en-US" sz="1600">
+              <a:solidFill>
+                <a:schemeClr val="tx1"/>
+              </a:solidFill>
+            </a:endParaRPr>
+          </a:p>
+          <a:p>
+            <a:pPr marL="0" indent="0">
+              <a:buNone/>
+            </a:pPr>
+            <a:endParaRPr lang="en-US" altLang="en-US" sz="1600">
+              <a:solidFill>
+                <a:schemeClr val="tx1"/>
+              </a:solidFill>
+            </a:endParaRPr>
+          </a:p>
+          <a:p>
+            <a:pPr marL="0" indent="0">
+              <a:buNone/>
+            </a:pPr>
+            <a:r>
+              <a:rPr lang="en-US" altLang="en-US" sz="1600">
+                <a:solidFill>
+                  <a:schemeClr val="tx1"/>
+                </a:solidFill>
+              </a:rPr>
+              <a:t>Examples of release tags:</a:t>
+            </a:r>
+            <a:endParaRPr lang="en-US" altLang="en-US" sz="1600">
+              <a:solidFill>
+                <a:schemeClr val="tx1"/>
+              </a:solidFill>
+            </a:endParaRPr>
+          </a:p>
+          <a:p>
+            <a:r>
+              <a:rPr lang="en-US" altLang="en-US" sz="1600">
+                <a:solidFill>
+                  <a:schemeClr val="tx1"/>
+                </a:solidFill>
+              </a:rPr>
+              <a:t>v1.0.0</a:t>
+            </a:r>
+            <a:endParaRPr lang="en-US" altLang="en-US" sz="1600">
+              <a:solidFill>
+                <a:schemeClr val="tx1"/>
+              </a:solidFill>
+            </a:endParaRPr>
+          </a:p>
+          <a:p>
+            <a:r>
+              <a:rPr lang="en-US" altLang="en-US" sz="1600">
+                <a:solidFill>
+                  <a:schemeClr val="tx1"/>
+                </a:solidFill>
+              </a:rPr>
+              <a:t>v2.1.0</a:t>
+            </a:r>
+            <a:endParaRPr lang="en-US" altLang="en-US" sz="1600">
+              <a:solidFill>
+                <a:schemeClr val="tx1"/>
+              </a:solidFill>
+            </a:endParaRPr>
+          </a:p>
+          <a:p>
+            <a:r>
+              <a:rPr lang="en-US" altLang="en-US" sz="1600">
+                <a:solidFill>
+                  <a:schemeClr val="tx1"/>
+                </a:solidFill>
+              </a:rPr>
+              <a:t>v3.0-beta</a:t>
+            </a:r>
+            <a:endParaRPr lang="en-US" altLang="en-US" sz="1600">
+              <a:solidFill>
+                <a:schemeClr val="tx1"/>
+              </a:solidFill>
+            </a:endParaRPr>
+          </a:p>
+        </p:txBody>
+      </p:sp>
+    </p:spTree>
+    <p:custDataLst>
+      <p:tags r:id="rId3"/>
+    </p:custDataLst>
+  </p:cSld>
+  <p:clrMapOvr>
+    <a:masterClrMapping/>
+  </p:clrMapOvr>
+</p:sld>
+</file>
+
+<file path=ppt/slides/slide31.xml><?xml version="1.0" encoding="utf-8"?>
+<p:sld xmlns:a="http://schemas.openxmlformats.org/drawingml/2006/main" xmlns:r="http://schemas.openxmlformats.org/officeDocument/2006/relationships" xmlns:p="http://schemas.openxmlformats.org/presentationml/2006/main">
+  <p:cSld>
+    <p:spTree>
+      <p:nvGrpSpPr>
+        <p:cNvPr id="1" name=""/>
+        <p:cNvGrpSpPr/>
+        <p:nvPr/>
+      </p:nvGrpSpPr>
+      <p:grpSpPr/>
+      <p:sp>
+        <p:nvSpPr>
+          <p:cNvPr id="2" name="Title 1"/>
+          <p:cNvSpPr>
+            <a:spLocks noGrp="1"/>
+          </p:cNvSpPr>
+          <p:nvPr>
+            <p:ph type="title"/>
+            <p:custDataLst>
+              <p:tags r:id="rId1"/>
+            </p:custDataLst>
+          </p:nvPr>
+        </p:nvSpPr>
+        <p:spPr/>
+        <p:txBody>
+          <a:bodyPr/>
+          <a:p>
+            <a:r>
+              <a:rPr lang="en-US" altLang="en-US"/>
+              <a:t>Git Workflow Strategies</a:t>
+            </a:r>
+            <a:endParaRPr lang="en-US" altLang="en-US"/>
+          </a:p>
+        </p:txBody>
+      </p:sp>
+      <p:sp>
+        <p:nvSpPr>
+          <p:cNvPr id="3" name="Content Placeholder 2"/>
+          <p:cNvSpPr>
+            <a:spLocks noGrp="1"/>
+          </p:cNvSpPr>
+          <p:nvPr>
+            <p:ph idx="1"/>
+            <p:custDataLst>
+              <p:tags r:id="rId2"/>
+            </p:custDataLst>
+          </p:nvPr>
+        </p:nvSpPr>
+        <p:spPr/>
+        <p:txBody>
+          <a:bodyPr>
+            <a:normAutofit/>
+          </a:bodyPr>
+          <a:p>
+            <a:r>
+              <a:rPr lang="en-US" altLang="en-US">
+                <a:solidFill>
+                  <a:schemeClr val="tx1"/>
+                </a:solidFill>
+              </a:rPr>
+              <a:t>Different teams use different Git strategies depending on the size and needs of the project.</a:t>
+            </a:r>
+            <a:endParaRPr lang="en-US" altLang="en-US">
+              <a:solidFill>
+                <a:schemeClr val="tx1"/>
+              </a:solidFill>
+            </a:endParaRPr>
+          </a:p>
+          <a:p>
+            <a:pPr marL="0" indent="0">
+              <a:buNone/>
+            </a:pPr>
+            <a:r>
+              <a:rPr lang="en-US" altLang="en-US" b="1">
+                <a:solidFill>
+                  <a:schemeClr val="tx1"/>
+                </a:solidFill>
+              </a:rPr>
+              <a:t>1. Central Workflow</a:t>
+            </a:r>
+            <a:endParaRPr lang="en-US" altLang="en-US" b="1">
+              <a:solidFill>
+                <a:schemeClr val="tx1"/>
+              </a:solidFill>
+            </a:endParaRPr>
+          </a:p>
+          <a:p>
+            <a:r>
+              <a:rPr lang="en-US" altLang="en-US">
+                <a:solidFill>
+                  <a:schemeClr val="tx1"/>
+                </a:solidFill>
+              </a:rPr>
+              <a:t>A single main branch is used.</a:t>
+            </a:r>
+            <a:endParaRPr lang="en-US" altLang="en-US">
+              <a:solidFill>
+                <a:schemeClr val="tx1"/>
+              </a:solidFill>
+            </a:endParaRPr>
+          </a:p>
+          <a:p>
+            <a:endParaRPr lang="en-US" altLang="en-US">
+              <a:solidFill>
+                <a:schemeClr val="tx1"/>
+              </a:solidFill>
+            </a:endParaRPr>
+          </a:p>
+          <a:p>
+            <a:r>
+              <a:rPr lang="en-US" altLang="en-US">
+                <a:solidFill>
+                  <a:schemeClr val="tx1"/>
+                </a:solidFill>
+              </a:rPr>
+              <a:t>Simple</a:t>
+            </a:r>
+            <a:endParaRPr lang="en-US" altLang="en-US">
+              <a:solidFill>
+                <a:schemeClr val="tx1"/>
+              </a:solidFill>
+            </a:endParaRPr>
+          </a:p>
+          <a:p>
+            <a:r>
+              <a:rPr lang="en-US" altLang="en-US">
+                <a:solidFill>
+                  <a:schemeClr val="tx1"/>
+                </a:solidFill>
+              </a:rPr>
+              <a:t>Good for small teams</a:t>
+            </a:r>
+            <a:endParaRPr lang="en-US" altLang="en-US">
+              <a:solidFill>
+                <a:schemeClr val="tx1"/>
+              </a:solidFill>
+            </a:endParaRPr>
+          </a:p>
+          <a:p>
+            <a:r>
+              <a:rPr lang="en-US" altLang="en-US">
+                <a:solidFill>
+                  <a:schemeClr val="tx1"/>
+                </a:solidFill>
+              </a:rPr>
+              <a:t>Less flexible</a:t>
+            </a:r>
+            <a:endParaRPr lang="en-US" altLang="en-US">
+              <a:solidFill>
+                <a:schemeClr val="tx1"/>
+              </a:solidFill>
+            </a:endParaRPr>
+          </a:p>
+          <a:p>
+            <a:pPr marL="0" indent="0">
+              <a:buNone/>
+            </a:pPr>
+            <a:endParaRPr lang="en-US" altLang="en-US" b="1">
+              <a:solidFill>
+                <a:schemeClr val="tx1"/>
+              </a:solidFill>
+            </a:endParaRPr>
+          </a:p>
+          <a:p>
+            <a:pPr marL="0" indent="0">
+              <a:buNone/>
+            </a:pPr>
+            <a:endParaRPr lang="en-US" altLang="en-US">
+              <a:solidFill>
+                <a:schemeClr val="tx1"/>
+              </a:solidFill>
+            </a:endParaRPr>
+          </a:p>
+        </p:txBody>
+      </p:sp>
+    </p:spTree>
+    <p:custDataLst>
+      <p:tags r:id="rId3"/>
+    </p:custDataLst>
+  </p:cSld>
+  <p:clrMapOvr>
+    <a:masterClrMapping/>
+  </p:clrMapOvr>
+</p:sld>
+</file>
+
+<file path=ppt/slides/slide32.xml><?xml version="1.0" encoding="utf-8"?>
+<p:sld xmlns:a="http://schemas.openxmlformats.org/drawingml/2006/main" xmlns:r="http://schemas.openxmlformats.org/officeDocument/2006/relationships" xmlns:p="http://schemas.openxmlformats.org/presentationml/2006/main">
+  <p:cSld>
+    <p:spTree>
+      <p:nvGrpSpPr>
+        <p:cNvPr id="1" name=""/>
+        <p:cNvGrpSpPr/>
+        <p:nvPr/>
+      </p:nvGrpSpPr>
+      <p:grpSpPr/>
+      <p:sp>
+        <p:nvSpPr>
+          <p:cNvPr id="2" name="Title 1"/>
+          <p:cNvSpPr>
+            <a:spLocks noGrp="1"/>
+          </p:cNvSpPr>
+          <p:nvPr>
+            <p:ph type="title"/>
+            <p:custDataLst>
+              <p:tags r:id="rId1"/>
+            </p:custDataLst>
+          </p:nvPr>
+        </p:nvSpPr>
+        <p:spPr/>
+        <p:txBody>
+          <a:bodyPr/>
+          <a:p>
+            <a:endParaRPr lang="en-US"/>
+          </a:p>
+        </p:txBody>
+      </p:sp>
+      <p:sp>
+        <p:nvSpPr>
+          <p:cNvPr id="3" name="Content Placeholder 2"/>
+          <p:cNvSpPr>
+            <a:spLocks noGrp="1"/>
+          </p:cNvSpPr>
+          <p:nvPr>
+            <p:ph idx="1"/>
+            <p:custDataLst>
+              <p:tags r:id="rId2"/>
+            </p:custDataLst>
+          </p:nvPr>
+        </p:nvSpPr>
+        <p:spPr/>
+        <p:txBody>
+          <a:bodyPr/>
+          <a:p>
+            <a:pPr marL="0" indent="0">
+              <a:buNone/>
+            </a:pPr>
+            <a:r>
+              <a:rPr lang="en-US" altLang="en-US" b="1">
+                <a:solidFill>
+                  <a:schemeClr val="tx1"/>
+                </a:solidFill>
+                <a:sym typeface="+mn-ea"/>
+              </a:rPr>
+              <a:t>2. Feature Branch Workflow</a:t>
+            </a:r>
+            <a:endParaRPr lang="en-US" altLang="en-US" b="1">
+              <a:solidFill>
+                <a:schemeClr val="tx1"/>
+              </a:solidFill>
+            </a:endParaRPr>
+          </a:p>
+          <a:p>
+            <a:r>
+              <a:rPr lang="en-US" altLang="en-US">
+                <a:solidFill>
+                  <a:schemeClr val="tx1"/>
+                </a:solidFill>
+                <a:sym typeface="+mn-ea"/>
+              </a:rPr>
+              <a:t>Each feature is developed in its own branch.</a:t>
+            </a:r>
+            <a:endParaRPr lang="en-US" altLang="en-US">
+              <a:solidFill>
+                <a:schemeClr val="tx1"/>
+              </a:solidFill>
+            </a:endParaRPr>
+          </a:p>
+          <a:p>
+            <a:endParaRPr lang="en-US" altLang="en-US">
+              <a:solidFill>
+                <a:schemeClr val="tx1"/>
+              </a:solidFill>
+            </a:endParaRPr>
+          </a:p>
+          <a:p>
+            <a:r>
+              <a:rPr lang="en-US" altLang="en-US">
+                <a:solidFill>
+                  <a:schemeClr val="tx1"/>
+                </a:solidFill>
+                <a:sym typeface="+mn-ea"/>
+              </a:rPr>
+              <a:t>Safer for bigger projects</a:t>
+            </a:r>
+            <a:endParaRPr lang="en-US" altLang="en-US">
+              <a:solidFill>
+                <a:schemeClr val="tx1"/>
+              </a:solidFill>
+            </a:endParaRPr>
+          </a:p>
+          <a:p>
+            <a:r>
+              <a:rPr lang="en-US" altLang="en-US">
+                <a:solidFill>
+                  <a:schemeClr val="tx1"/>
+                </a:solidFill>
+                <a:sym typeface="+mn-ea"/>
+              </a:rPr>
+              <a:t>Easier to review</a:t>
+            </a:r>
+            <a:endParaRPr lang="en-US" altLang="en-US">
+              <a:solidFill>
+                <a:schemeClr val="tx1"/>
+              </a:solidFill>
+            </a:endParaRPr>
+          </a:p>
+          <a:p>
+            <a:r>
+              <a:rPr lang="en-US" altLang="en-US">
+                <a:solidFill>
+                  <a:schemeClr val="tx1"/>
+                </a:solidFill>
+                <a:sym typeface="+mn-ea"/>
+              </a:rPr>
+              <a:t>Good for teamwork</a:t>
+            </a:r>
+            <a:endParaRPr lang="en-US"/>
+          </a:p>
+        </p:txBody>
+      </p:sp>
+    </p:spTree>
+    <p:custDataLst>
+      <p:tags r:id="rId3"/>
+    </p:custDataLst>
+  </p:cSld>
+  <p:clrMapOvr>
+    <a:masterClrMapping/>
+  </p:clrMapOvr>
+</p:sld>
+</file>
+
+<file path=ppt/slides/slide33.xml><?xml version="1.0" encoding="utf-8"?>
+<p:sld xmlns:a="http://schemas.openxmlformats.org/drawingml/2006/main" xmlns:r="http://schemas.openxmlformats.org/officeDocument/2006/relationships" xmlns:p="http://schemas.openxmlformats.org/presentationml/2006/main">
+  <p:cSld>
+    <p:spTree>
+      <p:nvGrpSpPr>
+        <p:cNvPr id="1" name=""/>
+        <p:cNvGrpSpPr/>
+        <p:nvPr/>
+      </p:nvGrpSpPr>
+      <p:grpSpPr/>
+      <p:sp>
+        <p:nvSpPr>
+          <p:cNvPr id="2" name="Title 1"/>
+          <p:cNvSpPr>
+            <a:spLocks noGrp="1"/>
+          </p:cNvSpPr>
+          <p:nvPr>
+            <p:ph type="title"/>
+            <p:custDataLst>
+              <p:tags r:id="rId1"/>
+            </p:custDataLst>
+          </p:nvPr>
+        </p:nvSpPr>
+        <p:spPr/>
+        <p:txBody>
+          <a:bodyPr/>
+          <a:p>
+            <a:endParaRPr lang="en-US"/>
+          </a:p>
+        </p:txBody>
+      </p:sp>
+      <p:sp>
+        <p:nvSpPr>
+          <p:cNvPr id="3" name="Content Placeholder 2"/>
+          <p:cNvSpPr>
+            <a:spLocks noGrp="1"/>
+          </p:cNvSpPr>
+          <p:nvPr>
+            <p:ph idx="1"/>
+            <p:custDataLst>
+              <p:tags r:id="rId2"/>
+            </p:custDataLst>
+          </p:nvPr>
+        </p:nvSpPr>
+        <p:spPr/>
+        <p:txBody>
+          <a:bodyPr/>
+          <a:p>
+            <a:pPr marL="0" indent="0">
+              <a:buNone/>
+            </a:pPr>
+            <a:r>
+              <a:rPr lang="en-US" altLang="en-US" b="1">
+                <a:solidFill>
+                  <a:schemeClr val="tx1"/>
+                </a:solidFill>
+              </a:rPr>
+              <a:t>3. Git Flow</a:t>
+            </a:r>
+            <a:endParaRPr lang="en-US" altLang="en-US" b="1">
+              <a:solidFill>
+                <a:schemeClr val="tx1"/>
+              </a:solidFill>
+            </a:endParaRPr>
+          </a:p>
+          <a:p>
+            <a:pPr marL="0" indent="0">
+              <a:buNone/>
+            </a:pPr>
+            <a:r>
+              <a:rPr lang="en-US" altLang="en-US">
+                <a:solidFill>
+                  <a:schemeClr val="tx1"/>
+                </a:solidFill>
+              </a:rPr>
+              <a:t>A more structured workflow with branches like:</a:t>
+            </a:r>
+            <a:endParaRPr lang="en-US" altLang="en-US">
+              <a:solidFill>
+                <a:schemeClr val="tx1"/>
+              </a:solidFill>
+            </a:endParaRPr>
+          </a:p>
+          <a:p>
+            <a:endParaRPr lang="en-US" altLang="en-US">
+              <a:solidFill>
+                <a:schemeClr val="tx1"/>
+              </a:solidFill>
+            </a:endParaRPr>
+          </a:p>
+          <a:p>
+            <a:r>
+              <a:rPr lang="en-US" altLang="en-US">
+                <a:solidFill>
+                  <a:schemeClr val="tx1"/>
+                </a:solidFill>
+              </a:rPr>
+              <a:t>main</a:t>
+            </a:r>
+            <a:endParaRPr lang="en-US" altLang="en-US">
+              <a:solidFill>
+                <a:schemeClr val="tx1"/>
+              </a:solidFill>
+            </a:endParaRPr>
+          </a:p>
+          <a:p>
+            <a:r>
+              <a:rPr lang="en-US" altLang="en-US">
+                <a:solidFill>
+                  <a:schemeClr val="tx1"/>
+                </a:solidFill>
+              </a:rPr>
+              <a:t>develop</a:t>
+            </a:r>
+            <a:endParaRPr lang="en-US" altLang="en-US">
+              <a:solidFill>
+                <a:schemeClr val="tx1"/>
+              </a:solidFill>
+            </a:endParaRPr>
+          </a:p>
+          <a:p>
+            <a:r>
+              <a:rPr lang="en-US" altLang="en-US">
+                <a:solidFill>
+                  <a:schemeClr val="tx1"/>
+                </a:solidFill>
+              </a:rPr>
+              <a:t>feature/*</a:t>
+            </a:r>
+            <a:endParaRPr lang="en-US" altLang="en-US">
+              <a:solidFill>
+                <a:schemeClr val="tx1"/>
+              </a:solidFill>
+            </a:endParaRPr>
+          </a:p>
+          <a:p>
+            <a:r>
+              <a:rPr lang="en-US" altLang="en-US">
+                <a:solidFill>
+                  <a:schemeClr val="tx1"/>
+                </a:solidFill>
+              </a:rPr>
+              <a:t>release/*</a:t>
+            </a:r>
+            <a:endParaRPr lang="en-US" altLang="en-US">
+              <a:solidFill>
+                <a:schemeClr val="tx1"/>
+              </a:solidFill>
+            </a:endParaRPr>
+          </a:p>
+          <a:p>
+            <a:r>
+              <a:rPr lang="en-US" altLang="en-US">
+                <a:solidFill>
+                  <a:schemeClr val="tx1"/>
+                </a:solidFill>
+              </a:rPr>
+              <a:t>hotfix/*</a:t>
+            </a:r>
+            <a:endParaRPr lang="en-US" altLang="en-US">
+              <a:solidFill>
+                <a:schemeClr val="tx1"/>
+              </a:solidFill>
+            </a:endParaRPr>
+          </a:p>
+          <a:p>
+            <a:pPr marL="0" indent="0">
+              <a:buNone/>
+            </a:pPr>
+            <a:r>
+              <a:rPr lang="en-US" altLang="en-US">
+                <a:solidFill>
+                  <a:schemeClr val="tx1"/>
+                </a:solidFill>
+              </a:rPr>
+              <a:t>This is useful for larger and more organized projects.</a:t>
+            </a:r>
+            <a:endParaRPr lang="en-US" altLang="en-US">
+              <a:solidFill>
+                <a:schemeClr val="tx1"/>
+              </a:solidFill>
+            </a:endParaRPr>
+          </a:p>
+        </p:txBody>
+      </p:sp>
+    </p:spTree>
+    <p:custDataLst>
+      <p:tags r:id="rId3"/>
+    </p:custDataLst>
+  </p:cSld>
+  <p:clrMapOvr>
+    <a:masterClrMapping/>
+  </p:clrMapOvr>
+</p:sld>
+</file>
+
+<file path=ppt/slides/slide34.xml><?xml version="1.0" encoding="utf-8"?>
+<p:sld xmlns:a="http://schemas.openxmlformats.org/drawingml/2006/main" xmlns:r="http://schemas.openxmlformats.org/officeDocument/2006/relationships" xmlns:p="http://schemas.openxmlformats.org/presentationml/2006/main">
+  <p:cSld>
+    <p:spTree>
+      <p:nvGrpSpPr>
+        <p:cNvPr id="1" name=""/>
+        <p:cNvGrpSpPr/>
+        <p:nvPr/>
+      </p:nvGrpSpPr>
+      <p:grpSpPr/>
+      <p:sp>
+        <p:nvSpPr>
+          <p:cNvPr id="2" name="Title 1"/>
+          <p:cNvSpPr>
+            <a:spLocks noGrp="1"/>
+          </p:cNvSpPr>
+          <p:nvPr>
+            <p:ph type="title"/>
+            <p:custDataLst>
+              <p:tags r:id="rId1"/>
+            </p:custDataLst>
+          </p:nvPr>
+        </p:nvSpPr>
+        <p:spPr/>
+        <p:txBody>
+          <a:bodyPr/>
+          <a:p>
+            <a:r>
+              <a:rPr lang="en-US" altLang="en-US"/>
+              <a:t>Trunk-Based Development</a:t>
+            </a:r>
+            <a:endParaRPr lang="en-US" altLang="en-US"/>
+          </a:p>
+        </p:txBody>
+      </p:sp>
+      <p:sp>
+        <p:nvSpPr>
+          <p:cNvPr id="3" name="Content Placeholder 2"/>
+          <p:cNvSpPr>
+            <a:spLocks noGrp="1"/>
+          </p:cNvSpPr>
+          <p:nvPr>
+            <p:ph idx="1"/>
+            <p:custDataLst>
+              <p:tags r:id="rId2"/>
+            </p:custDataLst>
+          </p:nvPr>
+        </p:nvSpPr>
+        <p:spPr/>
+        <p:txBody>
+          <a:bodyPr/>
+          <a:p>
+            <a:pPr marL="0" indent="0">
+              <a:buNone/>
+            </a:pPr>
+            <a:r>
+              <a:rPr lang="en-US" altLang="en-US">
+                <a:solidFill>
+                  <a:schemeClr val="tx1"/>
+                </a:solidFill>
+              </a:rPr>
+              <a:t>Developers work on short-lived branches and merge often.</a:t>
+            </a:r>
+            <a:endParaRPr lang="en-US" altLang="en-US">
+              <a:solidFill>
+                <a:schemeClr val="tx1"/>
+              </a:solidFill>
+            </a:endParaRPr>
+          </a:p>
+          <a:p>
+            <a:endParaRPr lang="en-US" altLang="en-US">
+              <a:solidFill>
+                <a:schemeClr val="tx1"/>
+              </a:solidFill>
+            </a:endParaRPr>
+          </a:p>
+          <a:p>
+            <a:r>
+              <a:rPr lang="en-US" altLang="en-US">
+                <a:solidFill>
+                  <a:schemeClr val="tx1"/>
+                </a:solidFill>
+              </a:rPr>
+              <a:t>Fast</a:t>
+            </a:r>
+            <a:endParaRPr lang="en-US" altLang="en-US">
+              <a:solidFill>
+                <a:schemeClr val="tx1"/>
+              </a:solidFill>
+            </a:endParaRPr>
+          </a:p>
+          <a:p>
+            <a:r>
+              <a:rPr lang="en-US" altLang="en-US">
+                <a:solidFill>
+                  <a:schemeClr val="tx1"/>
+                </a:solidFill>
+              </a:rPr>
+              <a:t>Keeps branches small</a:t>
+            </a:r>
+            <a:endParaRPr lang="en-US" altLang="en-US">
+              <a:solidFill>
+                <a:schemeClr val="tx1"/>
+              </a:solidFill>
+            </a:endParaRPr>
+          </a:p>
+          <a:p>
+            <a:r>
+              <a:rPr lang="en-US" altLang="en-US">
+                <a:solidFill>
+                  <a:schemeClr val="tx1"/>
+                </a:solidFill>
+              </a:rPr>
+              <a:t>Good for modern CI/CD teams</a:t>
+            </a:r>
+            <a:endParaRPr lang="en-US" altLang="en-US">
+              <a:solidFill>
+                <a:schemeClr val="tx1"/>
+              </a:solidFill>
+            </a:endParaRPr>
+          </a:p>
+        </p:txBody>
+      </p:sp>
+    </p:spTree>
+    <p:custDataLst>
+      <p:tags r:id="rId3"/>
+    </p:custDataLst>
+  </p:cSld>
+  <p:clrMapOvr>
+    <a:masterClrMapping/>
+  </p:clrMapOvr>
+</p:sld>
+</file>
+
+<file path=ppt/slides/slide35.xml><?xml version="1.0" encoding="utf-8"?>
+<p:sld xmlns:a="http://schemas.openxmlformats.org/drawingml/2006/main" xmlns:r="http://schemas.openxmlformats.org/officeDocument/2006/relationships" xmlns:p="http://schemas.openxmlformats.org/presentationml/2006/main">
+  <p:cSld>
+    <p:spTree>
+      <p:nvGrpSpPr>
+        <p:cNvPr id="1" name=""/>
+        <p:cNvGrpSpPr/>
+        <p:nvPr/>
+      </p:nvGrpSpPr>
+      <p:grpSpPr/>
+      <p:sp>
+        <p:nvSpPr>
+          <p:cNvPr id="2" name="Title 1"/>
+          <p:cNvSpPr>
+            <a:spLocks noGrp="1"/>
+          </p:cNvSpPr>
+          <p:nvPr>
+            <p:ph type="title"/>
+            <p:custDataLst>
+              <p:tags r:id="rId1"/>
+            </p:custDataLst>
+          </p:nvPr>
+        </p:nvSpPr>
+        <p:spPr/>
+        <p:txBody>
+          <a:bodyPr/>
+          <a:p>
+            <a:r>
+              <a:rPr lang="en-US" altLang="en-US"/>
+              <a:t>Summary of Key Git Concepts</a:t>
+            </a:r>
+            <a:endParaRPr lang="en-US" altLang="en-US"/>
+          </a:p>
+        </p:txBody>
+      </p:sp>
+      <p:sp>
+        <p:nvSpPr>
+          <p:cNvPr id="3" name="Content Placeholder 2"/>
+          <p:cNvSpPr>
+            <a:spLocks noGrp="1"/>
+          </p:cNvSpPr>
+          <p:nvPr>
+            <p:ph idx="1"/>
+            <p:custDataLst>
+              <p:tags r:id="rId2"/>
+            </p:custDataLst>
+          </p:nvPr>
+        </p:nvSpPr>
+        <p:spPr/>
+        <p:txBody>
+          <a:bodyPr/>
+          <a:p>
+            <a:pPr marL="0" indent="0">
+              <a:buNone/>
+            </a:pPr>
+            <a:r>
+              <a:rPr lang="en-US" altLang="en-US">
+                <a:solidFill>
+                  <a:schemeClr val="tx1"/>
+                </a:solidFill>
+              </a:rPr>
+              <a:t>The main ideas in Lecture 8 are:</a:t>
+            </a:r>
+            <a:endParaRPr lang="en-US" altLang="en-US">
+              <a:solidFill>
+                <a:schemeClr val="tx1"/>
+              </a:solidFill>
+            </a:endParaRPr>
+          </a:p>
+          <a:p>
+            <a:endParaRPr lang="en-US" altLang="en-US">
+              <a:solidFill>
+                <a:schemeClr val="tx1"/>
+              </a:solidFill>
+            </a:endParaRPr>
+          </a:p>
+          <a:p>
+            <a:r>
+              <a:rPr lang="en-US" altLang="en-US">
+                <a:solidFill>
+                  <a:schemeClr val="tx1"/>
+                </a:solidFill>
+              </a:rPr>
+              <a:t>Branching helps separate work</a:t>
+            </a:r>
+            <a:endParaRPr lang="en-US" altLang="en-US">
+              <a:solidFill>
+                <a:schemeClr val="tx1"/>
+              </a:solidFill>
+            </a:endParaRPr>
+          </a:p>
+          <a:p>
+            <a:r>
+              <a:rPr lang="en-US" altLang="en-US">
+                <a:solidFill>
+                  <a:schemeClr val="tx1"/>
+                </a:solidFill>
+              </a:rPr>
+              <a:t>Merging combines completed work</a:t>
+            </a:r>
+            <a:endParaRPr lang="en-US" altLang="en-US">
+              <a:solidFill>
+                <a:schemeClr val="tx1"/>
+              </a:solidFill>
+            </a:endParaRPr>
+          </a:p>
+          <a:p>
+            <a:r>
+              <a:rPr lang="en-US" altLang="en-US">
+                <a:solidFill>
+                  <a:schemeClr val="tx1"/>
+                </a:solidFill>
+              </a:rPr>
+              <a:t>Conflicts need manual resolution</a:t>
+            </a:r>
+            <a:endParaRPr lang="en-US" altLang="en-US">
+              <a:solidFill>
+                <a:schemeClr val="tx1"/>
+              </a:solidFill>
+            </a:endParaRPr>
+          </a:p>
+          <a:p>
+            <a:r>
+              <a:rPr lang="en-US" altLang="en-US">
+                <a:solidFill>
+                  <a:schemeClr val="tx1"/>
+                </a:solidFill>
+              </a:rPr>
+              <a:t>Rebase restructures commit history</a:t>
+            </a:r>
+            <a:endParaRPr lang="en-US" altLang="en-US">
+              <a:solidFill>
+                <a:schemeClr val="tx1"/>
+              </a:solidFill>
+            </a:endParaRPr>
+          </a:p>
+          <a:p>
+            <a:r>
+              <a:rPr lang="en-US" altLang="en-US">
+                <a:solidFill>
+                  <a:schemeClr val="tx1"/>
+                </a:solidFill>
+              </a:rPr>
+              <a:t>Tags mark releases or important checkpoints</a:t>
+            </a:r>
+            <a:endParaRPr lang="en-US" altLang="en-US">
+              <a:solidFill>
+                <a:schemeClr val="tx1"/>
+              </a:solidFill>
+            </a:endParaRPr>
+          </a:p>
+          <a:p>
+            <a:r>
+              <a:rPr lang="en-US" altLang="en-US">
+                <a:solidFill>
+                  <a:schemeClr val="tx1"/>
+                </a:solidFill>
+              </a:rPr>
+              <a:t>Releases are official project versions</a:t>
+            </a:r>
+            <a:endParaRPr lang="en-US" altLang="en-US">
+              <a:solidFill>
+                <a:schemeClr val="tx1"/>
+              </a:solidFill>
+            </a:endParaRPr>
+          </a:p>
+          <a:p>
+            <a:r>
+              <a:rPr lang="en-US" altLang="en-US">
+                <a:solidFill>
+                  <a:schemeClr val="tx1"/>
+                </a:solidFill>
+              </a:rPr>
+              <a:t>Workflow strategies guide collaboration</a:t>
+            </a:r>
+            <a:endParaRPr lang="en-US" altLang="en-US">
+              <a:solidFill>
+                <a:schemeClr val="tx1"/>
+              </a:solidFill>
+            </a:endParaRPr>
+          </a:p>
+        </p:txBody>
+      </p:sp>
+    </p:spTree>
+    <p:custDataLst>
+      <p:tags r:id="rId3"/>
+    </p:custDataLst>
+  </p:cSld>
+  <p:clrMapOvr>
+    <a:masterClrMapping/>
+  </p:clrMapOvr>
+</p:sld>
+</file>
+
+<file path=ppt/slides/slide36.xml><?xml version="1.0" encoding="utf-8"?>
+<p:sld xmlns:a="http://schemas.openxmlformats.org/drawingml/2006/main" xmlns:r="http://schemas.openxmlformats.org/officeDocument/2006/relationships" xmlns:p="http://schemas.openxmlformats.org/presentationml/2006/main">
+  <p:cSld>
+    <p:spTree>
+      <p:nvGrpSpPr>
+        <p:cNvPr id="1" name=""/>
+        <p:cNvGrpSpPr/>
+        <p:nvPr/>
+      </p:nvGrpSpPr>
+      <p:grpSpPr/>
+      <p:sp>
+        <p:nvSpPr>
+          <p:cNvPr id="2" name="Title 1"/>
+          <p:cNvSpPr>
+            <a:spLocks noGrp="1"/>
+          </p:cNvSpPr>
+          <p:nvPr>
+            <p:ph type="title"/>
+            <p:custDataLst>
+              <p:tags r:id="rId1"/>
+            </p:custDataLst>
+          </p:nvPr>
+        </p:nvSpPr>
+        <p:spPr/>
+        <p:txBody>
+          <a:bodyPr/>
+          <a:p>
+            <a:r>
+              <a:rPr lang="en-US" altLang="en-US"/>
+              <a:t>Common Commands Review</a:t>
+            </a:r>
+            <a:endParaRPr lang="en-US" altLang="en-US"/>
+          </a:p>
+        </p:txBody>
+      </p:sp>
+      <p:sp>
+        <p:nvSpPr>
+          <p:cNvPr id="3" name="Content Placeholder 2"/>
+          <p:cNvSpPr>
+            <a:spLocks noGrp="1"/>
+          </p:cNvSpPr>
+          <p:nvPr>
+            <p:ph idx="1"/>
+            <p:custDataLst>
+              <p:tags r:id="rId2"/>
+            </p:custDataLst>
+          </p:nvPr>
+        </p:nvSpPr>
+        <p:spPr/>
+        <p:txBody>
+          <a:bodyPr/>
+          <a:p>
+            <a:r>
+              <a:rPr lang="en-US" altLang="en-US">
+                <a:solidFill>
+                  <a:schemeClr val="tx1"/>
+                </a:solidFill>
+              </a:rPr>
+              <a:t>git branch</a:t>
+            </a:r>
+            <a:endParaRPr lang="en-US" altLang="en-US">
+              <a:solidFill>
+                <a:schemeClr val="tx1"/>
+              </a:solidFill>
+            </a:endParaRPr>
+          </a:p>
+          <a:p>
+            <a:r>
+              <a:rPr lang="en-US" altLang="en-US">
+                <a:solidFill>
+                  <a:schemeClr val="tx1"/>
+                </a:solidFill>
+              </a:rPr>
+              <a:t>git switch main</a:t>
+            </a:r>
+            <a:endParaRPr lang="en-US" altLang="en-US">
+              <a:solidFill>
+                <a:schemeClr val="tx1"/>
+              </a:solidFill>
+            </a:endParaRPr>
+          </a:p>
+          <a:p>
+            <a:r>
+              <a:rPr lang="en-US" altLang="en-US">
+                <a:solidFill>
+                  <a:schemeClr val="tx1"/>
+                </a:solidFill>
+              </a:rPr>
+              <a:t>git switch feature-login</a:t>
+            </a:r>
+            <a:endParaRPr lang="en-US" altLang="en-US">
+              <a:solidFill>
+                <a:schemeClr val="tx1"/>
+              </a:solidFill>
+            </a:endParaRPr>
+          </a:p>
+          <a:p>
+            <a:r>
+              <a:rPr lang="en-US" altLang="en-US">
+                <a:solidFill>
+                  <a:schemeClr val="tx1"/>
+                </a:solidFill>
+              </a:rPr>
+              <a:t>git merge feature-login</a:t>
+            </a:r>
+            <a:endParaRPr lang="en-US" altLang="en-US">
+              <a:solidFill>
+                <a:schemeClr val="tx1"/>
+              </a:solidFill>
+            </a:endParaRPr>
+          </a:p>
+          <a:p>
+            <a:r>
+              <a:rPr lang="en-US" altLang="en-US">
+                <a:solidFill>
+                  <a:schemeClr val="tx1"/>
+                </a:solidFill>
+              </a:rPr>
+              <a:t>git rebase main</a:t>
+            </a:r>
+            <a:endParaRPr lang="en-US" altLang="en-US">
+              <a:solidFill>
+                <a:schemeClr val="tx1"/>
+              </a:solidFill>
+            </a:endParaRPr>
+          </a:p>
+          <a:p>
+            <a:r>
+              <a:rPr lang="en-US" altLang="en-US">
+                <a:solidFill>
+                  <a:schemeClr val="tx1"/>
+                </a:solidFill>
+              </a:rPr>
+              <a:t>git tag v1.0</a:t>
+            </a:r>
+            <a:endParaRPr lang="en-US" altLang="en-US">
+              <a:solidFill>
+                <a:schemeClr val="tx1"/>
+              </a:solidFill>
+            </a:endParaRPr>
+          </a:p>
+          <a:p>
+            <a:r>
+              <a:rPr lang="en-US" altLang="en-US">
+                <a:solidFill>
+                  <a:schemeClr val="tx1"/>
+                </a:solidFill>
+              </a:rPr>
+              <a:t>git log --oneline</a:t>
+            </a:r>
+            <a:endParaRPr lang="en-US" altLang="en-US">
+              <a:solidFill>
+                <a:schemeClr val="tx1"/>
+              </a:solidFill>
+            </a:endParaRPr>
+          </a:p>
+          <a:p>
+            <a:r>
+              <a:rPr lang="en-US" altLang="en-US">
+                <a:solidFill>
+                  <a:schemeClr val="tx1"/>
+                </a:solidFill>
+              </a:rPr>
+              <a:t>git status</a:t>
+            </a:r>
+            <a:endParaRPr lang="en-US" altLang="en-US">
+              <a:solidFill>
+                <a:schemeClr val="tx1"/>
+              </a:solidFill>
+            </a:endParaRPr>
+          </a:p>
+        </p:txBody>
+      </p:sp>
+    </p:spTree>
+    <p:custDataLst>
+      <p:tags r:id="rId3"/>
+    </p:custDataLst>
+  </p:cSld>
+  <p:clrMapOvr>
+    <a:masterClrMapping/>
+  </p:clrMapOvr>
+</p:sld>
+</file>
+
+<file path=ppt/slides/slide37.xml><?xml version="1.0" encoding="utf-8"?>
+<p:sld xmlns:a="http://schemas.openxmlformats.org/drawingml/2006/main" xmlns:r="http://schemas.openxmlformats.org/officeDocument/2006/relationships" xmlns:p="http://schemas.openxmlformats.org/presentationml/2006/main">
+  <p:cSld>
+    <p:spTree>
+      <p:nvGrpSpPr>
+        <p:cNvPr id="1" name=""/>
+        <p:cNvGrpSpPr/>
+        <p:nvPr/>
+      </p:nvGrpSpPr>
+      <p:grpSpPr/>
+      <p:sp>
+        <p:nvSpPr>
+          <p:cNvPr id="2" name="Title 1"/>
+          <p:cNvSpPr>
+            <a:spLocks noGrp="1"/>
+          </p:cNvSpPr>
+          <p:nvPr>
+            <p:ph type="title"/>
+            <p:custDataLst>
+              <p:tags r:id="rId1"/>
+            </p:custDataLst>
+          </p:nvPr>
+        </p:nvSpPr>
+        <p:spPr/>
+        <p:txBody>
+          <a:bodyPr>
+            <a:noAutofit/>
+          </a:bodyPr>
+          <a:p>
+            <a:r>
+              <a:rPr lang="en-US" altLang="en-US" sz="4000">
+                <a:solidFill>
+                  <a:schemeClr val="tx1"/>
+                </a:solidFill>
+              </a:rPr>
+              <a:t>Beginner-Friendly Example</a:t>
+            </a:r>
+            <a:endParaRPr lang="en-US" altLang="en-US" sz="4000">
+              <a:solidFill>
+                <a:schemeClr val="tx1"/>
+              </a:solidFill>
+            </a:endParaRPr>
+          </a:p>
+        </p:txBody>
+      </p:sp>
+      <p:graphicFrame>
+        <p:nvGraphicFramePr>
+          <p:cNvPr id="4" name="Content Placeholder 3"/>
+          <p:cNvGraphicFramePr/>
+          <p:nvPr>
+            <p:ph idx="1"/>
+            <p:custDataLst>
+              <p:tags r:id="rId2"/>
+            </p:custDataLst>
+          </p:nvPr>
+        </p:nvGraphicFramePr>
+        <p:xfrm>
+          <a:off x="608400" y="1490400"/>
+          <a:ext cx="10968990" cy="381000"/>
+        </p:xfrm>
+        <a:graphic>
+          <a:graphicData uri="http://schemas.openxmlformats.org/drawingml/2006/table">
+            <a:tbl>
+              <a:tblPr firstRow="1" bandRow="1">
+                <a:tableStyleId>{5C22544A-7EE6-4342-B048-85BDC9FD1C3A}</a:tableStyleId>
+              </a:tblPr>
+              <a:tblGrid>
+                <a:gridCol w="10968990"/>
+              </a:tblGrid>
+              <a:tr h="381000">
+                <a:tc>
+                  <a:txBody>
+                    <a:bodyPr/>
+                    <a:p>
+                      <a:pPr>
+                        <a:buNone/>
+                      </a:pPr>
+                      <a:r>
+                        <a:rPr lang="en-US" altLang="en-US" sz="2000"/>
+                        <a:t>git init</a:t>
+                      </a:r>
+                      <a:endParaRPr lang="en-US" altLang="en-US" sz="2000"/>
+                    </a:p>
+                    <a:p>
+                      <a:pPr>
+                        <a:buNone/>
+                      </a:pPr>
+                      <a:r>
+                        <a:rPr lang="en-US" altLang="en-US" sz="2000"/>
+                        <a:t>git branch feature-login</a:t>
+                      </a:r>
+                      <a:endParaRPr lang="en-US" altLang="en-US" sz="2000"/>
+                    </a:p>
+                    <a:p>
+                      <a:pPr>
+                        <a:buNone/>
+                      </a:pPr>
+                      <a:r>
+                        <a:rPr lang="en-US" altLang="en-US" sz="2000"/>
+                        <a:t>git switch feature-login</a:t>
+                      </a:r>
+                      <a:endParaRPr lang="en-US" altLang="en-US" sz="2000"/>
+                    </a:p>
+                    <a:p>
+                      <a:pPr>
+                        <a:buNone/>
+                      </a:pPr>
+                      <a:endParaRPr lang="en-US" altLang="en-US" sz="2000"/>
+                    </a:p>
+                    <a:p>
+                      <a:pPr>
+                        <a:buNone/>
+                      </a:pPr>
+                      <a:r>
+                        <a:rPr lang="en-US" altLang="en-US" sz="2000"/>
+                        <a:t>echo "New feature code" &gt;&gt; app.txt</a:t>
+                      </a:r>
+                      <a:endParaRPr lang="en-US" altLang="en-US" sz="2000"/>
+                    </a:p>
+                    <a:p>
+                      <a:pPr>
+                        <a:buNone/>
+                      </a:pPr>
+                      <a:r>
+                        <a:rPr lang="en-US" altLang="en-US" sz="2000"/>
+                        <a:t>git add app.txt</a:t>
+                      </a:r>
+                      <a:endParaRPr lang="en-US" altLang="en-US" sz="2000"/>
+                    </a:p>
+                    <a:p>
+                      <a:pPr>
+                        <a:buNone/>
+                      </a:pPr>
+                      <a:r>
+                        <a:rPr lang="en-US" altLang="en-US" sz="2000"/>
+                        <a:t>git commit -m "Add login page"</a:t>
+                      </a:r>
+                      <a:endParaRPr lang="en-US" altLang="en-US" sz="2000"/>
+                    </a:p>
+                    <a:p>
+                      <a:pPr>
+                        <a:buNone/>
+                      </a:pPr>
+                      <a:endParaRPr lang="en-US" altLang="en-US" sz="2000"/>
+                    </a:p>
+                    <a:p>
+                      <a:pPr>
+                        <a:buNone/>
+                      </a:pPr>
+                      <a:r>
+                        <a:rPr lang="en-US" altLang="en-US" sz="2000"/>
+                        <a:t>git switch main</a:t>
+                      </a:r>
+                      <a:endParaRPr lang="en-US" altLang="en-US" sz="2000"/>
+                    </a:p>
+                    <a:p>
+                      <a:pPr>
+                        <a:buNone/>
+                      </a:pPr>
+                      <a:r>
+                        <a:rPr lang="en-US" altLang="en-US" sz="2000"/>
+                        <a:t>git merge feature-login</a:t>
+                      </a:r>
+                      <a:endParaRPr lang="en-US" altLang="en-US" sz="2000"/>
+                    </a:p>
+                  </a:txBody>
+                  <a:tcPr>
+                    <a:solidFill>
+                      <a:schemeClr val="tx1"/>
+                    </a:solidFill>
+                  </a:tcPr>
+                </a:tc>
+              </a:tr>
+            </a:tbl>
+          </a:graphicData>
+        </a:graphic>
+      </p:graphicFrame>
+      <p:sp>
+        <p:nvSpPr>
+          <p:cNvPr id="6" name="Text Box 5"/>
+          <p:cNvSpPr txBox="1"/>
+          <p:nvPr/>
+        </p:nvSpPr>
+        <p:spPr>
+          <a:xfrm>
+            <a:off x="608330" y="5021580"/>
+            <a:ext cx="10968990" cy="645160"/>
+          </a:xfrm>
+          <a:prstGeom prst="rect">
+            <a:avLst/>
+          </a:prstGeom>
+        </p:spPr>
+        <p:txBody>
+          <a:bodyPr wrap="square">
+            <a:spAutoFit/>
+          </a:bodyPr>
+          <a:p>
+            <a:pPr marL="0" indent="0"/>
+            <a:r>
+              <a:rPr b="0" i="0">
+                <a:solidFill>
+                  <a:schemeClr val="tx1"/>
+                </a:solidFill>
+                <a:latin typeface="Mona Sans VF"/>
+                <a:ea typeface="Mona Sans VF"/>
+              </a:rPr>
+              <a:t>This shows the basic process of creating a branch, making a change, and merging it back into the main branch.</a:t>
+            </a:r>
+            <a:endParaRPr b="0" i="0">
+              <a:solidFill>
+                <a:schemeClr val="tx1"/>
+              </a:solidFill>
+              <a:latin typeface="Mona Sans VF"/>
+              <a:ea typeface="Mona Sans VF"/>
+            </a:endParaRPr>
+          </a:p>
+        </p:txBody>
+      </p:sp>
+    </p:spTree>
+    <p:custDataLst>
+      <p:tags r:id="rId3"/>
+    </p:custDataLst>
+  </p:cSld>
+  <p:clrMapOvr>
+    <a:masterClrMapping/>
+  </p:clrMapOvr>
+</p:sld>
+</file>
+
+<file path=ppt/slides/slide38.xml><?xml version="1.0" encoding="utf-8"?>
+<p:sld xmlns:a="http://schemas.openxmlformats.org/drawingml/2006/main" xmlns:r="http://schemas.openxmlformats.org/officeDocument/2006/relationships" xmlns:p="http://schemas.openxmlformats.org/presentationml/2006/main">
+  <p:cSld>
+    <p:spTree>
+      <p:nvGrpSpPr>
+        <p:cNvPr id="1" name=""/>
+        <p:cNvGrpSpPr/>
+        <p:nvPr/>
+      </p:nvGrpSpPr>
+      <p:grpSpPr/>
+      <p:sp>
+        <p:nvSpPr>
+          <p:cNvPr id="2" name="Title 1"/>
+          <p:cNvSpPr>
+            <a:spLocks noGrp="1"/>
+          </p:cNvSpPr>
+          <p:nvPr>
+            <p:ph type="title"/>
+            <p:custDataLst>
+              <p:tags r:id="rId1"/>
+            </p:custDataLst>
+          </p:nvPr>
+        </p:nvSpPr>
+        <p:spPr/>
+        <p:txBody>
+          <a:bodyPr/>
+          <a:p>
+            <a:r>
+              <a:rPr lang="en-US" altLang="en-US"/>
+              <a:t>Best Practices</a:t>
+            </a:r>
+            <a:endParaRPr lang="en-US" altLang="en-US"/>
+          </a:p>
+        </p:txBody>
+      </p:sp>
+      <p:sp>
+        <p:nvSpPr>
+          <p:cNvPr id="3" name="Content Placeholder 2"/>
+          <p:cNvSpPr>
+            <a:spLocks noGrp="1"/>
+          </p:cNvSpPr>
+          <p:nvPr>
+            <p:ph idx="1"/>
+            <p:custDataLst>
+              <p:tags r:id="rId2"/>
+            </p:custDataLst>
+          </p:nvPr>
+        </p:nvSpPr>
+        <p:spPr/>
+        <p:txBody>
+          <a:bodyPr/>
+          <a:p>
+            <a:r>
+              <a:rPr lang="en-US" altLang="en-US">
+                <a:solidFill>
+                  <a:schemeClr val="tx1"/>
+                </a:solidFill>
+              </a:rPr>
+              <a:t>Use descriptive branch names such as feature-login or bugfix-header</a:t>
+            </a:r>
+            <a:endParaRPr lang="en-US" altLang="en-US">
+              <a:solidFill>
+                <a:schemeClr val="tx1"/>
+              </a:solidFill>
+            </a:endParaRPr>
+          </a:p>
+          <a:p>
+            <a:r>
+              <a:rPr lang="en-US" altLang="en-US">
+                <a:solidFill>
+                  <a:schemeClr val="tx1"/>
+                </a:solidFill>
+              </a:rPr>
+              <a:t>Commit often with clear messages</a:t>
+            </a:r>
+            <a:endParaRPr lang="en-US" altLang="en-US">
+              <a:solidFill>
+                <a:schemeClr val="tx1"/>
+              </a:solidFill>
+            </a:endParaRPr>
+          </a:p>
+          <a:p>
+            <a:r>
+              <a:rPr lang="en-US" altLang="en-US">
+                <a:solidFill>
+                  <a:schemeClr val="tx1"/>
+                </a:solidFill>
+              </a:rPr>
+              <a:t>Do not ignore merge conflicts</a:t>
+            </a:r>
+            <a:endParaRPr lang="en-US" altLang="en-US">
+              <a:solidFill>
+                <a:schemeClr val="tx1"/>
+              </a:solidFill>
+            </a:endParaRPr>
+          </a:p>
+          <a:p>
+            <a:r>
+              <a:rPr lang="en-US" altLang="en-US">
+                <a:solidFill>
+                  <a:schemeClr val="tx1"/>
+                </a:solidFill>
+              </a:rPr>
+              <a:t>Test code before merging</a:t>
+            </a:r>
+            <a:endParaRPr lang="en-US" altLang="en-US">
+              <a:solidFill>
+                <a:schemeClr val="tx1"/>
+              </a:solidFill>
+            </a:endParaRPr>
+          </a:p>
+          <a:p>
+            <a:r>
+              <a:rPr lang="en-US" altLang="en-US">
+                <a:solidFill>
+                  <a:schemeClr val="tx1"/>
+                </a:solidFill>
+              </a:rPr>
+              <a:t>Use tags for important releases</a:t>
+            </a:r>
+            <a:endParaRPr lang="en-US" altLang="en-US">
+              <a:solidFill>
+                <a:schemeClr val="tx1"/>
+              </a:solidFill>
+            </a:endParaRPr>
+          </a:p>
+          <a:p>
+            <a:r>
+              <a:rPr lang="en-US" altLang="en-US">
+                <a:solidFill>
+                  <a:schemeClr val="tx1"/>
+                </a:solidFill>
+              </a:rPr>
+              <a:t>Keep branch changes small and focused</a:t>
+            </a:r>
+            <a:endParaRPr lang="en-US" altLang="en-US">
+              <a:solidFill>
+                <a:schemeClr val="tx1"/>
+              </a:solidFill>
+            </a:endParaRPr>
+          </a:p>
+        </p:txBody>
+      </p:sp>
+    </p:spTree>
+    <p:custDataLst>
+      <p:tags r:id="rId3"/>
+    </p:custDataLst>
+  </p:cSld>
+  <p:clrMapOvr>
+    <a:masterClrMapping/>
+  </p:clrMapOvr>
+</p:sld>
+</file>
+
+<file path=ppt/slides/slide39.xml><?xml version="1.0" encoding="utf-8"?>
+<p:sld xmlns:a="http://schemas.openxmlformats.org/drawingml/2006/main" xmlns:r="http://schemas.openxmlformats.org/officeDocument/2006/relationships" xmlns:p="http://schemas.openxmlformats.org/presentationml/2006/main">
+  <p:cSld>
+    <p:spTree>
+      <p:nvGrpSpPr>
+        <p:cNvPr id="1" name=""/>
+        <p:cNvGrpSpPr/>
+        <p:nvPr/>
+      </p:nvGrpSpPr>
+      <p:grpSpPr/>
+      <p:sp>
+        <p:nvSpPr>
+          <p:cNvPr id="2" name="Title 1"/>
+          <p:cNvSpPr>
+            <a:spLocks noGrp="1"/>
+          </p:cNvSpPr>
+          <p:nvPr>
+            <p:ph type="title"/>
+            <p:custDataLst>
+              <p:tags r:id="rId1"/>
+            </p:custDataLst>
+          </p:nvPr>
+        </p:nvSpPr>
+        <p:spPr/>
+        <p:txBody>
+          <a:bodyPr/>
+          <a:p>
+            <a:r>
+              <a:rPr lang="en-US" altLang="en-US"/>
+              <a:t>Practice Questions</a:t>
+            </a:r>
+            <a:endParaRPr lang="en-US" altLang="en-US"/>
+          </a:p>
+        </p:txBody>
+      </p:sp>
+      <p:sp>
+        <p:nvSpPr>
+          <p:cNvPr id="3" name="Content Placeholder 2"/>
+          <p:cNvSpPr>
+            <a:spLocks noGrp="1"/>
+          </p:cNvSpPr>
+          <p:nvPr>
+            <p:ph idx="1"/>
+            <p:custDataLst>
+              <p:tags r:id="rId2"/>
+            </p:custDataLst>
+          </p:nvPr>
+        </p:nvSpPr>
+        <p:spPr/>
+        <p:txBody>
+          <a:bodyPr/>
+          <a:p>
+            <a:r>
+              <a:rPr lang="en-US" altLang="en-US">
+                <a:solidFill>
+                  <a:schemeClr val="tx1"/>
+                </a:solidFill>
+              </a:rPr>
+              <a:t>What is a branch?</a:t>
+            </a:r>
+            <a:endParaRPr lang="en-US" altLang="en-US">
+              <a:solidFill>
+                <a:schemeClr val="tx1"/>
+              </a:solidFill>
+            </a:endParaRPr>
+          </a:p>
+          <a:p>
+            <a:r>
+              <a:rPr lang="en-US" altLang="en-US">
+                <a:solidFill>
+                  <a:schemeClr val="tx1"/>
+                </a:solidFill>
+              </a:rPr>
+              <a:t>Why do merge conflicts happen?</a:t>
+            </a:r>
+            <a:endParaRPr lang="en-US" altLang="en-US">
+              <a:solidFill>
+                <a:schemeClr val="tx1"/>
+              </a:solidFill>
+            </a:endParaRPr>
+          </a:p>
+          <a:p>
+            <a:r>
+              <a:rPr lang="en-US" altLang="en-US">
+                <a:solidFill>
+                  <a:schemeClr val="tx1"/>
+                </a:solidFill>
+              </a:rPr>
+              <a:t>What is the purpose of a tag?</a:t>
+            </a:r>
+            <a:endParaRPr lang="en-US" altLang="en-US">
+              <a:solidFill>
+                <a:schemeClr val="tx1"/>
+              </a:solidFill>
+            </a:endParaRPr>
+          </a:p>
+          <a:p>
+            <a:r>
+              <a:rPr lang="en-US" altLang="en-US">
+                <a:solidFill>
+                  <a:schemeClr val="tx1"/>
+                </a:solidFill>
+              </a:rPr>
+              <a:t>What is the difference between merging and rebasing?</a:t>
+            </a:r>
+            <a:endParaRPr lang="en-US" altLang="en-US">
+              <a:solidFill>
+                <a:schemeClr val="tx1"/>
+              </a:solidFill>
+            </a:endParaRPr>
+          </a:p>
+          <a:p>
+            <a:r>
+              <a:rPr lang="en-US" altLang="en-US">
+                <a:solidFill>
+                  <a:schemeClr val="tx1"/>
+                </a:solidFill>
+              </a:rPr>
+              <a:t>Why are workflow strategies important in team projects?</a:t>
             </a:r>
             <a:endParaRPr lang="en-US" altLang="en-US">
               <a:solidFill>
@@ -5873,6 +9905,87 @@
 </p:tagLst>
 </file>
 
+<file path=ppt/tags/tag113.xml><?xml version="1.0" encoding="utf-8"?>
+<p:tagLst xmlns:p="http://schemas.openxmlformats.org/presentationml/2006/main">
+  <p:tag name="KSO_WM_UNIT_HIGHLIGHT" val="0"/>
+  <p:tag name="KSO_WM_UNIT_COMPATIBLE" val="0"/>
+  <p:tag name="KSO_WM_UNIT_DIAGRAM_ISNUMVISUAL" val="0"/>
+  <p:tag name="KSO_WM_UNIT_DIAGRAM_ISREFERUNIT" val="0"/>
+  <p:tag name="KSO_WM_UNIT_ID" val="_2**"/>
+  <p:tag name="KSO_WM_UNIT_LAYERLEVEL" val="1"/>
+  <p:tag name="KSO_WM_TAG_VERSION" val="1.0"/>
+  <p:tag name="KSO_WM_BEAUTIFY_FLAG" val="#wm#"/>
+</p:tagLst>
+</file>
+
+<file path=ppt/tags/tag114.xml><?xml version="1.0" encoding="utf-8"?>
+<p:tagLst xmlns:p="http://schemas.openxmlformats.org/presentationml/2006/main">
+  <p:tag name="KSO_WM_UNIT_HIGHLIGHT" val="0"/>
+  <p:tag name="KSO_WM_UNIT_COMPATIBLE" val="0"/>
+  <p:tag name="KSO_WM_UNIT_DIAGRAM_ISNUMVISUAL" val="0"/>
+  <p:tag name="KSO_WM_UNIT_DIAGRAM_ISREFERUNIT" val="0"/>
+  <p:tag name="KSO_WM_UNIT_ID" val="_2**"/>
+  <p:tag name="KSO_WM_UNIT_LAYERLEVEL" val="1"/>
+  <p:tag name="KSO_WM_TAG_VERSION" val="1.0"/>
+  <p:tag name="KSO_WM_BEAUTIFY_FLAG" val="#wm#"/>
+</p:tagLst>
+</file>
+
+<file path=ppt/tags/tag115.xml><?xml version="1.0" encoding="utf-8"?>
+<p:tagLst xmlns:p="http://schemas.openxmlformats.org/presentationml/2006/main">
+  <p:tag name="KSO_WM_BEAUTIFY_FLAG" val="#wm#"/>
+  <p:tag name="KSO_WM_TEMPLATE_CATEGORY" val="custom"/>
+  <p:tag name="KSO_WM_TEMPLATE_INDEX" val="20205081"/>
+</p:tagLst>
+</file>
+
+<file path=ppt/tags/tag116.xml><?xml version="1.0" encoding="utf-8"?>
+<p:tagLst xmlns:p="http://schemas.openxmlformats.org/presentationml/2006/main">
+  <p:tag name="KSO_WM_UNIT_HIGHLIGHT" val="0"/>
+  <p:tag name="KSO_WM_UNIT_COMPATIBLE" val="0"/>
+  <p:tag name="KSO_WM_UNIT_DIAGRAM_ISNUMVISUAL" val="0"/>
+  <p:tag name="KSO_WM_UNIT_DIAGRAM_ISREFERUNIT" val="0"/>
+  <p:tag name="KSO_WM_UNIT_ID" val="_2**"/>
+  <p:tag name="KSO_WM_UNIT_LAYERLEVEL" val="1"/>
+  <p:tag name="KSO_WM_TAG_VERSION" val="1.0"/>
+  <p:tag name="KSO_WM_BEAUTIFY_FLAG" val="#wm#"/>
+</p:tagLst>
+</file>
+
+<file path=ppt/tags/tag117.xml><?xml version="1.0" encoding="utf-8"?>
+<p:tagLst xmlns:p="http://schemas.openxmlformats.org/presentationml/2006/main">
+  <p:tag name="KSO_WM_UNIT_HIGHLIGHT" val="0"/>
+  <p:tag name="KSO_WM_UNIT_COMPATIBLE" val="0"/>
+  <p:tag name="KSO_WM_UNIT_DIAGRAM_ISNUMVISUAL" val="0"/>
+  <p:tag name="KSO_WM_UNIT_DIAGRAM_ISREFERUNIT" val="0"/>
+  <p:tag name="KSO_WM_UNIT_ID" val="_2**"/>
+  <p:tag name="KSO_WM_UNIT_LAYERLEVEL" val="1"/>
+  <p:tag name="KSO_WM_TAG_VERSION" val="1.0"/>
+  <p:tag name="KSO_WM_BEAUTIFY_FLAG" val="#wm#"/>
+</p:tagLst>
+</file>
+
+<file path=ppt/tags/tag118.xml><?xml version="1.0" encoding="utf-8"?>
+<p:tagLst xmlns:p="http://schemas.openxmlformats.org/presentationml/2006/main">
+  <p:tag name="KSO_WM_BEAUTIFY_FLAG" val="#wm#"/>
+  <p:tag name="KSO_WM_TEMPLATE_CATEGORY" val="custom"/>
+  <p:tag name="KSO_WM_TEMPLATE_INDEX" val="20205081"/>
+</p:tagLst>
+</file>
+
+<file path=ppt/tags/tag119.xml><?xml version="1.0" encoding="utf-8"?>
+<p:tagLst xmlns:p="http://schemas.openxmlformats.org/presentationml/2006/main">
+  <p:tag name="KSO_WM_UNIT_HIGHLIGHT" val="0"/>
+  <p:tag name="KSO_WM_UNIT_COMPATIBLE" val="0"/>
+  <p:tag name="KSO_WM_UNIT_DIAGRAM_ISNUMVISUAL" val="0"/>
+  <p:tag name="KSO_WM_UNIT_DIAGRAM_ISREFERUNIT" val="0"/>
+  <p:tag name="KSO_WM_UNIT_ID" val="_2**"/>
+  <p:tag name="KSO_WM_UNIT_LAYERLEVEL" val="1"/>
+  <p:tag name="KSO_WM_TAG_VERSION" val="1.0"/>
+  <p:tag name="KSO_WM_BEAUTIFY_FLAG" val="#wm#"/>
+</p:tagLst>
+</file>
+
 <file path=ppt/tags/tag12.xml><?xml version="1.0" encoding="utf-8"?>
 <p:tagLst xmlns:p="http://schemas.openxmlformats.org/presentationml/2006/main">
   <p:tag name="KSO_WM_UNIT_HIGHLIGHT" val="0"/>
@@ -5886,6 +9999,121 @@
 </p:tagLst>
 </file>
 
+<file path=ppt/tags/tag120.xml><?xml version="1.0" encoding="utf-8"?>
+<p:tagLst xmlns:p="http://schemas.openxmlformats.org/presentationml/2006/main">
+  <p:tag name="KSO_WM_UNIT_HIGHLIGHT" val="0"/>
+  <p:tag name="KSO_WM_UNIT_COMPATIBLE" val="0"/>
+  <p:tag name="KSO_WM_UNIT_DIAGRAM_ISNUMVISUAL" val="0"/>
+  <p:tag name="KSO_WM_UNIT_DIAGRAM_ISREFERUNIT" val="0"/>
+  <p:tag name="KSO_WM_UNIT_ID" val="_2**"/>
+  <p:tag name="KSO_WM_UNIT_LAYERLEVEL" val="1"/>
+  <p:tag name="KSO_WM_TAG_VERSION" val="1.0"/>
+  <p:tag name="KSO_WM_BEAUTIFY_FLAG" val="#wm#"/>
+</p:tagLst>
+</file>
+
+<file path=ppt/tags/tag121.xml><?xml version="1.0" encoding="utf-8"?>
+<p:tagLst xmlns:p="http://schemas.openxmlformats.org/presentationml/2006/main">
+  <p:tag name="KSO_WM_BEAUTIFY_FLAG" val="#wm#"/>
+  <p:tag name="KSO_WM_TEMPLATE_CATEGORY" val="custom"/>
+  <p:tag name="KSO_WM_TEMPLATE_INDEX" val="20205081"/>
+</p:tagLst>
+</file>
+
+<file path=ppt/tags/tag122.xml><?xml version="1.0" encoding="utf-8"?>
+<p:tagLst xmlns:p="http://schemas.openxmlformats.org/presentationml/2006/main">
+  <p:tag name="KSO_WM_UNIT_HIGHLIGHT" val="0"/>
+  <p:tag name="KSO_WM_UNIT_COMPATIBLE" val="0"/>
+  <p:tag name="KSO_WM_UNIT_DIAGRAM_ISNUMVISUAL" val="0"/>
+  <p:tag name="KSO_WM_UNIT_DIAGRAM_ISREFERUNIT" val="0"/>
+  <p:tag name="KSO_WM_UNIT_ID" val="_2**"/>
+  <p:tag name="KSO_WM_UNIT_LAYERLEVEL" val="1"/>
+  <p:tag name="KSO_WM_TAG_VERSION" val="1.0"/>
+  <p:tag name="KSO_WM_BEAUTIFY_FLAG" val="#wm#"/>
+</p:tagLst>
+</file>
+
+<file path=ppt/tags/tag123.xml><?xml version="1.0" encoding="utf-8"?>
+<p:tagLst xmlns:p="http://schemas.openxmlformats.org/presentationml/2006/main">
+  <p:tag name="KSO_WM_UNIT_HIGHLIGHT" val="0"/>
+  <p:tag name="KSO_WM_UNIT_COMPATIBLE" val="0"/>
+  <p:tag name="KSO_WM_UNIT_DIAGRAM_ISNUMVISUAL" val="0"/>
+  <p:tag name="KSO_WM_UNIT_DIAGRAM_ISREFERUNIT" val="0"/>
+  <p:tag name="KSO_WM_UNIT_ID" val="_2**"/>
+  <p:tag name="KSO_WM_UNIT_LAYERLEVEL" val="1"/>
+  <p:tag name="KSO_WM_TAG_VERSION" val="1.0"/>
+  <p:tag name="KSO_WM_BEAUTIFY_FLAG" val="#wm#"/>
+</p:tagLst>
+</file>
+
+<file path=ppt/tags/tag124.xml><?xml version="1.0" encoding="utf-8"?>
+<p:tagLst xmlns:p="http://schemas.openxmlformats.org/presentationml/2006/main">
+  <p:tag name="KSO_WM_BEAUTIFY_FLAG" val="#wm#"/>
+  <p:tag name="KSO_WM_TEMPLATE_CATEGORY" val="custom"/>
+  <p:tag name="KSO_WM_TEMPLATE_INDEX" val="20205081"/>
+</p:tagLst>
+</file>
+
+<file path=ppt/tags/tag125.xml><?xml version="1.0" encoding="utf-8"?>
+<p:tagLst xmlns:p="http://schemas.openxmlformats.org/presentationml/2006/main">
+  <p:tag name="KSO_WM_UNIT_HIGHLIGHT" val="0"/>
+  <p:tag name="KSO_WM_UNIT_COMPATIBLE" val="0"/>
+  <p:tag name="KSO_WM_UNIT_DIAGRAM_ISNUMVISUAL" val="0"/>
+  <p:tag name="KSO_WM_UNIT_DIAGRAM_ISREFERUNIT" val="0"/>
+  <p:tag name="KSO_WM_UNIT_ID" val="_2**"/>
+  <p:tag name="KSO_WM_UNIT_LAYERLEVEL" val="1"/>
+  <p:tag name="KSO_WM_TAG_VERSION" val="1.0"/>
+  <p:tag name="KSO_WM_BEAUTIFY_FLAG" val="#wm#"/>
+</p:tagLst>
+</file>
+
+<file path=ppt/tags/tag126.xml><?xml version="1.0" encoding="utf-8"?>
+<p:tagLst xmlns:p="http://schemas.openxmlformats.org/presentationml/2006/main">
+  <p:tag name="KSO_WM_UNIT_HIGHLIGHT" val="0"/>
+  <p:tag name="KSO_WM_UNIT_COMPATIBLE" val="0"/>
+  <p:tag name="KSO_WM_UNIT_DIAGRAM_ISNUMVISUAL" val="0"/>
+  <p:tag name="KSO_WM_UNIT_DIAGRAM_ISREFERUNIT" val="0"/>
+  <p:tag name="KSO_WM_UNIT_ID" val="_2**"/>
+  <p:tag name="KSO_WM_UNIT_LAYERLEVEL" val="1"/>
+  <p:tag name="KSO_WM_TAG_VERSION" val="1.0"/>
+  <p:tag name="KSO_WM_BEAUTIFY_FLAG" val="#wm#"/>
+</p:tagLst>
+</file>
+
+<file path=ppt/tags/tag127.xml><?xml version="1.0" encoding="utf-8"?>
+<p:tagLst xmlns:p="http://schemas.openxmlformats.org/presentationml/2006/main">
+  <p:tag name="KSO_WM_BEAUTIFY_FLAG" val="#wm#"/>
+  <p:tag name="KSO_WM_TEMPLATE_CATEGORY" val="custom"/>
+  <p:tag name="KSO_WM_TEMPLATE_INDEX" val="20205081"/>
+</p:tagLst>
+</file>
+
+<file path=ppt/tags/tag128.xml><?xml version="1.0" encoding="utf-8"?>
+<p:tagLst xmlns:p="http://schemas.openxmlformats.org/presentationml/2006/main">
+  <p:tag name="KSO_WM_UNIT_HIGHLIGHT" val="0"/>
+  <p:tag name="KSO_WM_UNIT_COMPATIBLE" val="0"/>
+  <p:tag name="KSO_WM_UNIT_DIAGRAM_ISNUMVISUAL" val="0"/>
+  <p:tag name="KSO_WM_UNIT_DIAGRAM_ISREFERUNIT" val="0"/>
+  <p:tag name="KSO_WM_UNIT_ID" val="_2**"/>
+  <p:tag name="KSO_WM_UNIT_LAYERLEVEL" val="1"/>
+  <p:tag name="KSO_WM_TAG_VERSION" val="1.0"/>
+  <p:tag name="KSO_WM_BEAUTIFY_FLAG" val="#wm#"/>
+</p:tagLst>
+</file>
+
+<file path=ppt/tags/tag129.xml><?xml version="1.0" encoding="utf-8"?>
+<p:tagLst xmlns:p="http://schemas.openxmlformats.org/presentationml/2006/main">
+  <p:tag name="KSO_WM_UNIT_HIGHLIGHT" val="0"/>
+  <p:tag name="KSO_WM_UNIT_COMPATIBLE" val="0"/>
+  <p:tag name="KSO_WM_UNIT_DIAGRAM_ISNUMVISUAL" val="0"/>
+  <p:tag name="KSO_WM_UNIT_DIAGRAM_ISREFERUNIT" val="0"/>
+  <p:tag name="KSO_WM_UNIT_ID" val="_2**"/>
+  <p:tag name="KSO_WM_UNIT_LAYERLEVEL" val="1"/>
+  <p:tag name="KSO_WM_TAG_VERSION" val="1.0"/>
+  <p:tag name="KSO_WM_BEAUTIFY_FLAG" val="#wm#"/>
+</p:tagLst>
+</file>
+
 <file path=ppt/tags/tag13.xml><?xml version="1.0" encoding="utf-8"?>
 <p:tagLst xmlns:p="http://schemas.openxmlformats.org/presentationml/2006/main">
   <p:tag name="KSO_WM_UNIT_HIGHLIGHT" val="0"/>
@@ -5899,6 +10127,115 @@
 </p:tagLst>
 </file>
 
+<file path=ppt/tags/tag130.xml><?xml version="1.0" encoding="utf-8"?>
+<p:tagLst xmlns:p="http://schemas.openxmlformats.org/presentationml/2006/main">
+  <p:tag name="TABLE_ENDDRAG_ORIGIN_RECT" val="863*50"/>
+  <p:tag name="TABLE_ENDDRAG_RECT" val="47*171*863*50"/>
+</p:tagLst>
+</file>
+
+<file path=ppt/tags/tag131.xml><?xml version="1.0" encoding="utf-8"?>
+<p:tagLst xmlns:p="http://schemas.openxmlformats.org/presentationml/2006/main">
+  <p:tag name="KSO_WM_BEAUTIFY_FLAG" val="#wm#"/>
+  <p:tag name="KSO_WM_TEMPLATE_CATEGORY" val="custom"/>
+  <p:tag name="KSO_WM_TEMPLATE_INDEX" val="20205081"/>
+</p:tagLst>
+</file>
+
+<file path=ppt/tags/tag132.xml><?xml version="1.0" encoding="utf-8"?>
+<p:tagLst xmlns:p="http://schemas.openxmlformats.org/presentationml/2006/main">
+  <p:tag name="KSO_WM_UNIT_HIGHLIGHT" val="0"/>
+  <p:tag name="KSO_WM_UNIT_COMPATIBLE" val="0"/>
+  <p:tag name="KSO_WM_UNIT_DIAGRAM_ISNUMVISUAL" val="0"/>
+  <p:tag name="KSO_WM_UNIT_DIAGRAM_ISREFERUNIT" val="0"/>
+  <p:tag name="KSO_WM_UNIT_ID" val="_2**"/>
+  <p:tag name="KSO_WM_UNIT_LAYERLEVEL" val="1"/>
+  <p:tag name="KSO_WM_TAG_VERSION" val="1.0"/>
+  <p:tag name="KSO_WM_BEAUTIFY_FLAG" val="#wm#"/>
+</p:tagLst>
+</file>
+
+<file path=ppt/tags/tag133.xml><?xml version="1.0" encoding="utf-8"?>
+<p:tagLst xmlns:p="http://schemas.openxmlformats.org/presentationml/2006/main">
+  <p:tag name="KSO_WM_UNIT_HIGHLIGHT" val="0"/>
+  <p:tag name="KSO_WM_UNIT_COMPATIBLE" val="0"/>
+  <p:tag name="KSO_WM_UNIT_DIAGRAM_ISNUMVISUAL" val="0"/>
+  <p:tag name="KSO_WM_UNIT_DIAGRAM_ISREFERUNIT" val="0"/>
+  <p:tag name="KSO_WM_UNIT_ID" val="_2**"/>
+  <p:tag name="KSO_WM_UNIT_LAYERLEVEL" val="1"/>
+  <p:tag name="KSO_WM_TAG_VERSION" val="1.0"/>
+  <p:tag name="KSO_WM_BEAUTIFY_FLAG" val="#wm#"/>
+</p:tagLst>
+</file>
+
+<file path=ppt/tags/tag134.xml><?xml version="1.0" encoding="utf-8"?>
+<p:tagLst xmlns:p="http://schemas.openxmlformats.org/presentationml/2006/main">
+  <p:tag name="KSO_WM_BEAUTIFY_FLAG" val="#wm#"/>
+  <p:tag name="KSO_WM_TEMPLATE_CATEGORY" val="custom"/>
+  <p:tag name="KSO_WM_TEMPLATE_INDEX" val="20205081"/>
+</p:tagLst>
+</file>
+
+<file path=ppt/tags/tag135.xml><?xml version="1.0" encoding="utf-8"?>
+<p:tagLst xmlns:p="http://schemas.openxmlformats.org/presentationml/2006/main">
+  <p:tag name="KSO_WM_UNIT_HIGHLIGHT" val="0"/>
+  <p:tag name="KSO_WM_UNIT_COMPATIBLE" val="0"/>
+  <p:tag name="KSO_WM_UNIT_DIAGRAM_ISNUMVISUAL" val="0"/>
+  <p:tag name="KSO_WM_UNIT_DIAGRAM_ISREFERUNIT" val="0"/>
+  <p:tag name="KSO_WM_UNIT_ID" val="_2**"/>
+  <p:tag name="KSO_WM_UNIT_LAYERLEVEL" val="1"/>
+  <p:tag name="KSO_WM_TAG_VERSION" val="1.0"/>
+  <p:tag name="KSO_WM_BEAUTIFY_FLAG" val="#wm#"/>
+</p:tagLst>
+</file>
+
+<file path=ppt/tags/tag136.xml><?xml version="1.0" encoding="utf-8"?>
+<p:tagLst xmlns:p="http://schemas.openxmlformats.org/presentationml/2006/main">
+  <p:tag name="KSO_WM_UNIT_HIGHLIGHT" val="0"/>
+  <p:tag name="KSO_WM_UNIT_COMPATIBLE" val="0"/>
+  <p:tag name="KSO_WM_UNIT_DIAGRAM_ISNUMVISUAL" val="0"/>
+  <p:tag name="KSO_WM_UNIT_DIAGRAM_ISREFERUNIT" val="0"/>
+  <p:tag name="KSO_WM_UNIT_ID" val="_2**"/>
+  <p:tag name="KSO_WM_UNIT_LAYERLEVEL" val="1"/>
+  <p:tag name="KSO_WM_TAG_VERSION" val="1.0"/>
+  <p:tag name="KSO_WM_BEAUTIFY_FLAG" val="#wm#"/>
+</p:tagLst>
+</file>
+
+<file path=ppt/tags/tag137.xml><?xml version="1.0" encoding="utf-8"?>
+<p:tagLst xmlns:p="http://schemas.openxmlformats.org/presentationml/2006/main">
+  <p:tag name="KSO_WM_BEAUTIFY_FLAG" val="#wm#"/>
+  <p:tag name="KSO_WM_TEMPLATE_CATEGORY" val="custom"/>
+  <p:tag name="KSO_WM_TEMPLATE_INDEX" val="20205081"/>
+</p:tagLst>
+</file>
+
+<file path=ppt/tags/tag138.xml><?xml version="1.0" encoding="utf-8"?>
+<p:tagLst xmlns:p="http://schemas.openxmlformats.org/presentationml/2006/main">
+  <p:tag name="KSO_WM_UNIT_HIGHLIGHT" val="0"/>
+  <p:tag name="KSO_WM_UNIT_COMPATIBLE" val="0"/>
+  <p:tag name="KSO_WM_UNIT_DIAGRAM_ISNUMVISUAL" val="0"/>
+  <p:tag name="KSO_WM_UNIT_DIAGRAM_ISREFERUNIT" val="0"/>
+  <p:tag name="KSO_WM_UNIT_ID" val="_2**"/>
+  <p:tag name="KSO_WM_UNIT_LAYERLEVEL" val="1"/>
+  <p:tag name="KSO_WM_TAG_VERSION" val="1.0"/>
+  <p:tag name="KSO_WM_BEAUTIFY_FLAG" val="#wm#"/>
+</p:tagLst>
+</file>
+
+<file path=ppt/tags/tag139.xml><?xml version="1.0" encoding="utf-8"?>
+<p:tagLst xmlns:p="http://schemas.openxmlformats.org/presentationml/2006/main">
+  <p:tag name="KSO_WM_UNIT_HIGHLIGHT" val="0"/>
+  <p:tag name="KSO_WM_UNIT_COMPATIBLE" val="0"/>
+  <p:tag name="KSO_WM_UNIT_DIAGRAM_ISNUMVISUAL" val="0"/>
+  <p:tag name="KSO_WM_UNIT_DIAGRAM_ISREFERUNIT" val="0"/>
+  <p:tag name="KSO_WM_UNIT_ID" val="_2**"/>
+  <p:tag name="KSO_WM_UNIT_LAYERLEVEL" val="1"/>
+  <p:tag name="KSO_WM_TAG_VERSION" val="1.0"/>
+  <p:tag name="KSO_WM_BEAUTIFY_FLAG" val="#wm#"/>
+</p:tagLst>
+</file>
+
 <file path=ppt/tags/tag14.xml><?xml version="1.0" encoding="utf-8"?>
 <p:tagLst xmlns:p="http://schemas.openxmlformats.org/presentationml/2006/main">
   <p:tag name="KSO_WM_UNIT_HIGHLIGHT" val="0"/>
@@ -5912,6 +10249,116 @@
 </p:tagLst>
 </file>
 
+<file path=ppt/tags/tag140.xml><?xml version="1.0" encoding="utf-8"?>
+<p:tagLst xmlns:p="http://schemas.openxmlformats.org/presentationml/2006/main">
+  <p:tag name="KSO_WM_BEAUTIFY_FLAG" val="#wm#"/>
+  <p:tag name="KSO_WM_TEMPLATE_CATEGORY" val="custom"/>
+  <p:tag name="KSO_WM_TEMPLATE_INDEX" val="20205081"/>
+</p:tagLst>
+</file>
+
+<file path=ppt/tags/tag141.xml><?xml version="1.0" encoding="utf-8"?>
+<p:tagLst xmlns:p="http://schemas.openxmlformats.org/presentationml/2006/main">
+  <p:tag name="KSO_WM_UNIT_HIGHLIGHT" val="0"/>
+  <p:tag name="KSO_WM_UNIT_COMPATIBLE" val="0"/>
+  <p:tag name="KSO_WM_UNIT_DIAGRAM_ISNUMVISUAL" val="0"/>
+  <p:tag name="KSO_WM_UNIT_DIAGRAM_ISREFERUNIT" val="0"/>
+  <p:tag name="KSO_WM_UNIT_ID" val="_2**"/>
+  <p:tag name="KSO_WM_UNIT_LAYERLEVEL" val="1"/>
+  <p:tag name="KSO_WM_TAG_VERSION" val="1.0"/>
+  <p:tag name="KSO_WM_BEAUTIFY_FLAG" val="#wm#"/>
+</p:tagLst>
+</file>
+
+<file path=ppt/tags/tag142.xml><?xml version="1.0" encoding="utf-8"?>
+<p:tagLst xmlns:p="http://schemas.openxmlformats.org/presentationml/2006/main">
+  <p:tag name="KSO_WM_UNIT_HIGHLIGHT" val="0"/>
+  <p:tag name="KSO_WM_UNIT_COMPATIBLE" val="0"/>
+  <p:tag name="KSO_WM_UNIT_DIAGRAM_ISNUMVISUAL" val="0"/>
+  <p:tag name="KSO_WM_UNIT_DIAGRAM_ISREFERUNIT" val="0"/>
+  <p:tag name="KSO_WM_UNIT_ID" val="_2**"/>
+  <p:tag name="KSO_WM_UNIT_LAYERLEVEL" val="1"/>
+  <p:tag name="KSO_WM_TAG_VERSION" val="1.0"/>
+  <p:tag name="KSO_WM_BEAUTIFY_FLAG" val="#wm#"/>
+</p:tagLst>
+</file>
+
+<file path=ppt/tags/tag143.xml><?xml version="1.0" encoding="utf-8"?>
+<p:tagLst xmlns:p="http://schemas.openxmlformats.org/presentationml/2006/main">
+  <p:tag name="KSO_WM_BEAUTIFY_FLAG" val="#wm#"/>
+  <p:tag name="KSO_WM_TEMPLATE_CATEGORY" val="custom"/>
+  <p:tag name="KSO_WM_TEMPLATE_INDEX" val="20205081"/>
+</p:tagLst>
+</file>
+
+<file path=ppt/tags/tag144.xml><?xml version="1.0" encoding="utf-8"?>
+<p:tagLst xmlns:p="http://schemas.openxmlformats.org/presentationml/2006/main">
+  <p:tag name="KSO_WM_UNIT_HIGHLIGHT" val="0"/>
+  <p:tag name="KSO_WM_UNIT_COMPATIBLE" val="0"/>
+  <p:tag name="KSO_WM_UNIT_DIAGRAM_ISNUMVISUAL" val="0"/>
+  <p:tag name="KSO_WM_UNIT_DIAGRAM_ISREFERUNIT" val="0"/>
+  <p:tag name="KSO_WM_UNIT_ID" val="_2**"/>
+  <p:tag name="KSO_WM_UNIT_LAYERLEVEL" val="1"/>
+  <p:tag name="KSO_WM_TAG_VERSION" val="1.0"/>
+  <p:tag name="KSO_WM_BEAUTIFY_FLAG" val="#wm#"/>
+</p:tagLst>
+</file>
+
+<file path=ppt/tags/tag145.xml><?xml version="1.0" encoding="utf-8"?>
+<p:tagLst xmlns:p="http://schemas.openxmlformats.org/presentationml/2006/main">
+  <p:tag name="KSO_WM_UNIT_HIGHLIGHT" val="0"/>
+  <p:tag name="KSO_WM_UNIT_COMPATIBLE" val="0"/>
+  <p:tag name="KSO_WM_UNIT_DIAGRAM_ISNUMVISUAL" val="0"/>
+  <p:tag name="KSO_WM_UNIT_DIAGRAM_ISREFERUNIT" val="0"/>
+  <p:tag name="KSO_WM_UNIT_ID" val="_2**"/>
+  <p:tag name="KSO_WM_UNIT_LAYERLEVEL" val="1"/>
+  <p:tag name="KSO_WM_TAG_VERSION" val="1.0"/>
+  <p:tag name="KSO_WM_BEAUTIFY_FLAG" val="#wm#"/>
+</p:tagLst>
+</file>
+
+<file path=ppt/tags/tag146.xml><?xml version="1.0" encoding="utf-8"?>
+<p:tagLst xmlns:p="http://schemas.openxmlformats.org/presentationml/2006/main">
+  <p:tag name="KSO_WM_BEAUTIFY_FLAG" val="#wm#"/>
+  <p:tag name="KSO_WM_TEMPLATE_CATEGORY" val="custom"/>
+  <p:tag name="KSO_WM_TEMPLATE_INDEX" val="20205081"/>
+</p:tagLst>
+</file>
+
+<file path=ppt/tags/tag147.xml><?xml version="1.0" encoding="utf-8"?>
+<p:tagLst xmlns:p="http://schemas.openxmlformats.org/presentationml/2006/main">
+  <p:tag name="KSO_WM_UNIT_HIGHLIGHT" val="0"/>
+  <p:tag name="KSO_WM_UNIT_COMPATIBLE" val="0"/>
+  <p:tag name="KSO_WM_UNIT_DIAGRAM_ISNUMVISUAL" val="0"/>
+  <p:tag name="KSO_WM_UNIT_DIAGRAM_ISREFERUNIT" val="0"/>
+  <p:tag name="KSO_WM_UNIT_ID" val="_2**"/>
+  <p:tag name="KSO_WM_UNIT_LAYERLEVEL" val="1"/>
+  <p:tag name="KSO_WM_TAG_VERSION" val="1.0"/>
+  <p:tag name="KSO_WM_BEAUTIFY_FLAG" val="#wm#"/>
+</p:tagLst>
+</file>
+
+<file path=ppt/tags/tag148.xml><?xml version="1.0" encoding="utf-8"?>
+<p:tagLst xmlns:p="http://schemas.openxmlformats.org/presentationml/2006/main">
+  <p:tag name="KSO_WM_UNIT_HIGHLIGHT" val="0"/>
+  <p:tag name="KSO_WM_UNIT_COMPATIBLE" val="0"/>
+  <p:tag name="KSO_WM_UNIT_DIAGRAM_ISNUMVISUAL" val="0"/>
+  <p:tag name="KSO_WM_UNIT_DIAGRAM_ISREFERUNIT" val="0"/>
+  <p:tag name="KSO_WM_UNIT_ID" val="_2**"/>
+  <p:tag name="KSO_WM_UNIT_LAYERLEVEL" val="1"/>
+  <p:tag name="KSO_WM_TAG_VERSION" val="1.0"/>
+  <p:tag name="KSO_WM_BEAUTIFY_FLAG" val="#wm#"/>
+</p:tagLst>
+</file>
+
+<file path=ppt/tags/tag149.xml><?xml version="1.0" encoding="utf-8"?>
+<p:tagLst xmlns:p="http://schemas.openxmlformats.org/presentationml/2006/main">
+  <p:tag name="KSO_WM_BEAUTIFY_FLAG" val="#wm#"/>
+  <p:tag name="KSO_WM_TEMPLATE_CATEGORY" val="custom"/>
+  <p:tag name="KSO_WM_TEMPLATE_INDEX" val="20205081"/>
+</p:tagLst>
+</file>
+
 <file path=ppt/tags/tag15.xml><?xml version="1.0" encoding="utf-8"?>
 <p:tagLst xmlns:p="http://schemas.openxmlformats.org/presentationml/2006/main">
   <p:tag name="KSO_WM_UNIT_HIGHLIGHT" val="0"/>
@@ -5925,6 +10372,121 @@
 </p:tagLst>
 </file>
 
+<file path=ppt/tags/tag150.xml><?xml version="1.0" encoding="utf-8"?>
+<p:tagLst xmlns:p="http://schemas.openxmlformats.org/presentationml/2006/main">
+  <p:tag name="KSO_WM_UNIT_HIGHLIGHT" val="0"/>
+  <p:tag name="KSO_WM_UNIT_COMPATIBLE" val="0"/>
+  <p:tag name="KSO_WM_UNIT_DIAGRAM_ISNUMVISUAL" val="0"/>
+  <p:tag name="KSO_WM_UNIT_DIAGRAM_ISREFERUNIT" val="0"/>
+  <p:tag name="KSO_WM_UNIT_ID" val="_2**"/>
+  <p:tag name="KSO_WM_UNIT_LAYERLEVEL" val="1"/>
+  <p:tag name="KSO_WM_TAG_VERSION" val="1.0"/>
+  <p:tag name="KSO_WM_BEAUTIFY_FLAG" val="#wm#"/>
+</p:tagLst>
+</file>
+
+<file path=ppt/tags/tag151.xml><?xml version="1.0" encoding="utf-8"?>
+<p:tagLst xmlns:p="http://schemas.openxmlformats.org/presentationml/2006/main">
+  <p:tag name="KSO_WM_UNIT_HIGHLIGHT" val="0"/>
+  <p:tag name="KSO_WM_UNIT_COMPATIBLE" val="0"/>
+  <p:tag name="KSO_WM_UNIT_DIAGRAM_ISNUMVISUAL" val="0"/>
+  <p:tag name="KSO_WM_UNIT_DIAGRAM_ISREFERUNIT" val="0"/>
+  <p:tag name="KSO_WM_UNIT_ID" val="_2**"/>
+  <p:tag name="KSO_WM_UNIT_LAYERLEVEL" val="1"/>
+  <p:tag name="KSO_WM_TAG_VERSION" val="1.0"/>
+  <p:tag name="KSO_WM_BEAUTIFY_FLAG" val="#wm#"/>
+</p:tagLst>
+</file>
+
+<file path=ppt/tags/tag152.xml><?xml version="1.0" encoding="utf-8"?>
+<p:tagLst xmlns:p="http://schemas.openxmlformats.org/presentationml/2006/main">
+  <p:tag name="KSO_WM_BEAUTIFY_FLAG" val="#wm#"/>
+  <p:tag name="KSO_WM_TEMPLATE_CATEGORY" val="custom"/>
+  <p:tag name="KSO_WM_TEMPLATE_INDEX" val="20205081"/>
+</p:tagLst>
+</file>
+
+<file path=ppt/tags/tag153.xml><?xml version="1.0" encoding="utf-8"?>
+<p:tagLst xmlns:p="http://schemas.openxmlformats.org/presentationml/2006/main">
+  <p:tag name="KSO_WM_UNIT_HIGHLIGHT" val="0"/>
+  <p:tag name="KSO_WM_UNIT_COMPATIBLE" val="0"/>
+  <p:tag name="KSO_WM_UNIT_DIAGRAM_ISNUMVISUAL" val="0"/>
+  <p:tag name="KSO_WM_UNIT_DIAGRAM_ISREFERUNIT" val="0"/>
+  <p:tag name="KSO_WM_UNIT_ID" val="_2**"/>
+  <p:tag name="KSO_WM_UNIT_LAYERLEVEL" val="1"/>
+  <p:tag name="KSO_WM_TAG_VERSION" val="1.0"/>
+  <p:tag name="KSO_WM_BEAUTIFY_FLAG" val="#wm#"/>
+</p:tagLst>
+</file>
+
+<file path=ppt/tags/tag154.xml><?xml version="1.0" encoding="utf-8"?>
+<p:tagLst xmlns:p="http://schemas.openxmlformats.org/presentationml/2006/main">
+  <p:tag name="KSO_WM_UNIT_HIGHLIGHT" val="0"/>
+  <p:tag name="KSO_WM_UNIT_COMPATIBLE" val="0"/>
+  <p:tag name="KSO_WM_UNIT_DIAGRAM_ISNUMVISUAL" val="0"/>
+  <p:tag name="KSO_WM_UNIT_DIAGRAM_ISREFERUNIT" val="0"/>
+  <p:tag name="KSO_WM_UNIT_ID" val="_2**"/>
+  <p:tag name="KSO_WM_UNIT_LAYERLEVEL" val="1"/>
+  <p:tag name="KSO_WM_TAG_VERSION" val="1.0"/>
+  <p:tag name="KSO_WM_BEAUTIFY_FLAG" val="#wm#"/>
+</p:tagLst>
+</file>
+
+<file path=ppt/tags/tag155.xml><?xml version="1.0" encoding="utf-8"?>
+<p:tagLst xmlns:p="http://schemas.openxmlformats.org/presentationml/2006/main">
+  <p:tag name="KSO_WM_BEAUTIFY_FLAG" val="#wm#"/>
+  <p:tag name="KSO_WM_TEMPLATE_CATEGORY" val="custom"/>
+  <p:tag name="KSO_WM_TEMPLATE_INDEX" val="20205081"/>
+</p:tagLst>
+</file>
+
+<file path=ppt/tags/tag156.xml><?xml version="1.0" encoding="utf-8"?>
+<p:tagLst xmlns:p="http://schemas.openxmlformats.org/presentationml/2006/main">
+  <p:tag name="KSO_WM_UNIT_HIGHLIGHT" val="0"/>
+  <p:tag name="KSO_WM_UNIT_COMPATIBLE" val="0"/>
+  <p:tag name="KSO_WM_UNIT_DIAGRAM_ISNUMVISUAL" val="0"/>
+  <p:tag name="KSO_WM_UNIT_DIAGRAM_ISREFERUNIT" val="0"/>
+  <p:tag name="KSO_WM_UNIT_ID" val="_2**"/>
+  <p:tag name="KSO_WM_UNIT_LAYERLEVEL" val="1"/>
+  <p:tag name="KSO_WM_TAG_VERSION" val="1.0"/>
+  <p:tag name="KSO_WM_BEAUTIFY_FLAG" val="#wm#"/>
+</p:tagLst>
+</file>
+
+<file path=ppt/tags/tag157.xml><?xml version="1.0" encoding="utf-8"?>
+<p:tagLst xmlns:p="http://schemas.openxmlformats.org/presentationml/2006/main">
+  <p:tag name="KSO_WM_UNIT_HIGHLIGHT" val="0"/>
+  <p:tag name="KSO_WM_UNIT_COMPATIBLE" val="0"/>
+  <p:tag name="KSO_WM_UNIT_DIAGRAM_ISNUMVISUAL" val="0"/>
+  <p:tag name="KSO_WM_UNIT_DIAGRAM_ISREFERUNIT" val="0"/>
+  <p:tag name="KSO_WM_UNIT_ID" val="_2**"/>
+  <p:tag name="KSO_WM_UNIT_LAYERLEVEL" val="1"/>
+  <p:tag name="KSO_WM_TAG_VERSION" val="1.0"/>
+  <p:tag name="KSO_WM_BEAUTIFY_FLAG" val="#wm#"/>
+</p:tagLst>
+</file>
+
+<file path=ppt/tags/tag158.xml><?xml version="1.0" encoding="utf-8"?>
+<p:tagLst xmlns:p="http://schemas.openxmlformats.org/presentationml/2006/main">
+  <p:tag name="KSO_WM_BEAUTIFY_FLAG" val="#wm#"/>
+  <p:tag name="KSO_WM_TEMPLATE_CATEGORY" val="custom"/>
+  <p:tag name="KSO_WM_TEMPLATE_INDEX" val="20205081"/>
+</p:tagLst>
+</file>
+
+<file path=ppt/tags/tag159.xml><?xml version="1.0" encoding="utf-8"?>
+<p:tagLst xmlns:p="http://schemas.openxmlformats.org/presentationml/2006/main">
+  <p:tag name="KSO_WM_UNIT_HIGHLIGHT" val="0"/>
+  <p:tag name="KSO_WM_UNIT_COMPATIBLE" val="0"/>
+  <p:tag name="KSO_WM_UNIT_DIAGRAM_ISNUMVISUAL" val="0"/>
+  <p:tag name="KSO_WM_UNIT_DIAGRAM_ISREFERUNIT" val="0"/>
+  <p:tag name="KSO_WM_UNIT_ID" val="_2**"/>
+  <p:tag name="KSO_WM_UNIT_LAYERLEVEL" val="1"/>
+  <p:tag name="KSO_WM_TAG_VERSION" val="1.0"/>
+  <p:tag name="KSO_WM_BEAUTIFY_FLAG" val="#wm#"/>
+</p:tagLst>
+</file>
+
 <file path=ppt/tags/tag16.xml><?xml version="1.0" encoding="utf-8"?>
 <p:tagLst xmlns:p="http://schemas.openxmlformats.org/presentationml/2006/main">
   <p:tag name="KSO_WM_UNIT_HIGHLIGHT" val="0"/>
@@ -5938,6 +10500,121 @@
 </p:tagLst>
 </file>
 
+<file path=ppt/tags/tag160.xml><?xml version="1.0" encoding="utf-8"?>
+<p:tagLst xmlns:p="http://schemas.openxmlformats.org/presentationml/2006/main">
+  <p:tag name="KSO_WM_UNIT_HIGHLIGHT" val="0"/>
+  <p:tag name="KSO_WM_UNIT_COMPATIBLE" val="0"/>
+  <p:tag name="KSO_WM_UNIT_DIAGRAM_ISNUMVISUAL" val="0"/>
+  <p:tag name="KSO_WM_UNIT_DIAGRAM_ISREFERUNIT" val="0"/>
+  <p:tag name="KSO_WM_UNIT_ID" val="_2**"/>
+  <p:tag name="KSO_WM_UNIT_LAYERLEVEL" val="1"/>
+  <p:tag name="KSO_WM_TAG_VERSION" val="1.0"/>
+  <p:tag name="KSO_WM_BEAUTIFY_FLAG" val="#wm#"/>
+</p:tagLst>
+</file>
+
+<file path=ppt/tags/tag161.xml><?xml version="1.0" encoding="utf-8"?>
+<p:tagLst xmlns:p="http://schemas.openxmlformats.org/presentationml/2006/main">
+  <p:tag name="KSO_WM_BEAUTIFY_FLAG" val="#wm#"/>
+  <p:tag name="KSO_WM_TEMPLATE_CATEGORY" val="custom"/>
+  <p:tag name="KSO_WM_TEMPLATE_INDEX" val="20205081"/>
+</p:tagLst>
+</file>
+
+<file path=ppt/tags/tag162.xml><?xml version="1.0" encoding="utf-8"?>
+<p:tagLst xmlns:p="http://schemas.openxmlformats.org/presentationml/2006/main">
+  <p:tag name="KSO_WM_UNIT_HIGHLIGHT" val="0"/>
+  <p:tag name="KSO_WM_UNIT_COMPATIBLE" val="0"/>
+  <p:tag name="KSO_WM_UNIT_DIAGRAM_ISNUMVISUAL" val="0"/>
+  <p:tag name="KSO_WM_UNIT_DIAGRAM_ISREFERUNIT" val="0"/>
+  <p:tag name="KSO_WM_UNIT_ID" val="_2**"/>
+  <p:tag name="KSO_WM_UNIT_LAYERLEVEL" val="1"/>
+  <p:tag name="KSO_WM_TAG_VERSION" val="1.0"/>
+  <p:tag name="KSO_WM_BEAUTIFY_FLAG" val="#wm#"/>
+</p:tagLst>
+</file>
+
+<file path=ppt/tags/tag163.xml><?xml version="1.0" encoding="utf-8"?>
+<p:tagLst xmlns:p="http://schemas.openxmlformats.org/presentationml/2006/main">
+  <p:tag name="KSO_WM_UNIT_HIGHLIGHT" val="0"/>
+  <p:tag name="KSO_WM_UNIT_COMPATIBLE" val="0"/>
+  <p:tag name="KSO_WM_UNIT_DIAGRAM_ISNUMVISUAL" val="0"/>
+  <p:tag name="KSO_WM_UNIT_DIAGRAM_ISREFERUNIT" val="0"/>
+  <p:tag name="KSO_WM_UNIT_ID" val="_2**"/>
+  <p:tag name="KSO_WM_UNIT_LAYERLEVEL" val="1"/>
+  <p:tag name="KSO_WM_TAG_VERSION" val="1.0"/>
+  <p:tag name="KSO_WM_BEAUTIFY_FLAG" val="#wm#"/>
+</p:tagLst>
+</file>
+
+<file path=ppt/tags/tag164.xml><?xml version="1.0" encoding="utf-8"?>
+<p:tagLst xmlns:p="http://schemas.openxmlformats.org/presentationml/2006/main">
+  <p:tag name="KSO_WM_BEAUTIFY_FLAG" val="#wm#"/>
+  <p:tag name="KSO_WM_TEMPLATE_CATEGORY" val="custom"/>
+  <p:tag name="KSO_WM_TEMPLATE_INDEX" val="20205081"/>
+</p:tagLst>
+</file>
+
+<file path=ppt/tags/tag165.xml><?xml version="1.0" encoding="utf-8"?>
+<p:tagLst xmlns:p="http://schemas.openxmlformats.org/presentationml/2006/main">
+  <p:tag name="KSO_WM_UNIT_HIGHLIGHT" val="0"/>
+  <p:tag name="KSO_WM_UNIT_COMPATIBLE" val="0"/>
+  <p:tag name="KSO_WM_UNIT_DIAGRAM_ISNUMVISUAL" val="0"/>
+  <p:tag name="KSO_WM_UNIT_DIAGRAM_ISREFERUNIT" val="0"/>
+  <p:tag name="KSO_WM_UNIT_ID" val="_2**"/>
+  <p:tag name="KSO_WM_UNIT_LAYERLEVEL" val="1"/>
+  <p:tag name="KSO_WM_TAG_VERSION" val="1.0"/>
+  <p:tag name="KSO_WM_BEAUTIFY_FLAG" val="#wm#"/>
+</p:tagLst>
+</file>
+
+<file path=ppt/tags/tag166.xml><?xml version="1.0" encoding="utf-8"?>
+<p:tagLst xmlns:p="http://schemas.openxmlformats.org/presentationml/2006/main">
+  <p:tag name="KSO_WM_UNIT_HIGHLIGHT" val="0"/>
+  <p:tag name="KSO_WM_UNIT_COMPATIBLE" val="0"/>
+  <p:tag name="KSO_WM_UNIT_DIAGRAM_ISNUMVISUAL" val="0"/>
+  <p:tag name="KSO_WM_UNIT_DIAGRAM_ISREFERUNIT" val="0"/>
+  <p:tag name="KSO_WM_UNIT_ID" val="_2**"/>
+  <p:tag name="KSO_WM_UNIT_LAYERLEVEL" val="1"/>
+  <p:tag name="KSO_WM_TAG_VERSION" val="1.0"/>
+  <p:tag name="KSO_WM_BEAUTIFY_FLAG" val="#wm#"/>
+</p:tagLst>
+</file>
+
+<file path=ppt/tags/tag167.xml><?xml version="1.0" encoding="utf-8"?>
+<p:tagLst xmlns:p="http://schemas.openxmlformats.org/presentationml/2006/main">
+  <p:tag name="KSO_WM_BEAUTIFY_FLAG" val="#wm#"/>
+  <p:tag name="KSO_WM_TEMPLATE_CATEGORY" val="custom"/>
+  <p:tag name="KSO_WM_TEMPLATE_INDEX" val="20205081"/>
+</p:tagLst>
+</file>
+
+<file path=ppt/tags/tag168.xml><?xml version="1.0" encoding="utf-8"?>
+<p:tagLst xmlns:p="http://schemas.openxmlformats.org/presentationml/2006/main">
+  <p:tag name="KSO_WM_UNIT_HIGHLIGHT" val="0"/>
+  <p:tag name="KSO_WM_UNIT_COMPATIBLE" val="0"/>
+  <p:tag name="KSO_WM_UNIT_DIAGRAM_ISNUMVISUAL" val="0"/>
+  <p:tag name="KSO_WM_UNIT_DIAGRAM_ISREFERUNIT" val="0"/>
+  <p:tag name="KSO_WM_UNIT_ID" val="_2**"/>
+  <p:tag name="KSO_WM_UNIT_LAYERLEVEL" val="1"/>
+  <p:tag name="KSO_WM_TAG_VERSION" val="1.0"/>
+  <p:tag name="KSO_WM_BEAUTIFY_FLAG" val="#wm#"/>
+</p:tagLst>
+</file>
+
+<file path=ppt/tags/tag169.xml><?xml version="1.0" encoding="utf-8"?>
+<p:tagLst xmlns:p="http://schemas.openxmlformats.org/presentationml/2006/main">
+  <p:tag name="KSO_WM_UNIT_HIGHLIGHT" val="0"/>
+  <p:tag name="KSO_WM_UNIT_COMPATIBLE" val="0"/>
+  <p:tag name="KSO_WM_UNIT_DIAGRAM_ISNUMVISUAL" val="0"/>
+  <p:tag name="KSO_WM_UNIT_DIAGRAM_ISREFERUNIT" val="0"/>
+  <p:tag name="KSO_WM_UNIT_ID" val="_2**"/>
+  <p:tag name="KSO_WM_UNIT_LAYERLEVEL" val="1"/>
+  <p:tag name="KSO_WM_TAG_VERSION" val="1.0"/>
+  <p:tag name="KSO_WM_BEAUTIFY_FLAG" val="#wm#"/>
+</p:tagLst>
+</file>
+
 <file path=ppt/tags/tag17.xml><?xml version="1.0" encoding="utf-8"?>
 <p:tagLst xmlns:p="http://schemas.openxmlformats.org/presentationml/2006/main">
   <p:tag name="KSO_WM_UNIT_HIGHLIGHT" val="0"/>
@@ -5948,6 +10625,116 @@
   <p:tag name="KSO_WM_UNIT_LAYERLEVEL" val="1"/>
   <p:tag name="KSO_WM_TAG_VERSION" val="1.0"/>
   <p:tag name="KSO_WM_BEAUTIFY_FLAG" val="#wm#"/>
+</p:tagLst>
+</file>
+
+<file path=ppt/tags/tag170.xml><?xml version="1.0" encoding="utf-8"?>
+<p:tagLst xmlns:p="http://schemas.openxmlformats.org/presentationml/2006/main">
+  <p:tag name="KSO_WM_BEAUTIFY_FLAG" val="#wm#"/>
+  <p:tag name="KSO_WM_TEMPLATE_CATEGORY" val="custom"/>
+  <p:tag name="KSO_WM_TEMPLATE_INDEX" val="20205081"/>
+</p:tagLst>
+</file>
+
+<file path=ppt/tags/tag171.xml><?xml version="1.0" encoding="utf-8"?>
+<p:tagLst xmlns:p="http://schemas.openxmlformats.org/presentationml/2006/main">
+  <p:tag name="KSO_WM_UNIT_HIGHLIGHT" val="0"/>
+  <p:tag name="KSO_WM_UNIT_COMPATIBLE" val="0"/>
+  <p:tag name="KSO_WM_UNIT_DIAGRAM_ISNUMVISUAL" val="0"/>
+  <p:tag name="KSO_WM_UNIT_DIAGRAM_ISREFERUNIT" val="0"/>
+  <p:tag name="KSO_WM_UNIT_ID" val="_2**"/>
+  <p:tag name="KSO_WM_UNIT_LAYERLEVEL" val="1"/>
+  <p:tag name="KSO_WM_TAG_VERSION" val="1.0"/>
+  <p:tag name="KSO_WM_BEAUTIFY_FLAG" val="#wm#"/>
+</p:tagLst>
+</file>
+
+<file path=ppt/tags/tag172.xml><?xml version="1.0" encoding="utf-8"?>
+<p:tagLst xmlns:p="http://schemas.openxmlformats.org/presentationml/2006/main">
+  <p:tag name="KSO_WM_UNIT_HIGHLIGHT" val="0"/>
+  <p:tag name="KSO_WM_UNIT_COMPATIBLE" val="0"/>
+  <p:tag name="KSO_WM_UNIT_DIAGRAM_ISNUMVISUAL" val="0"/>
+  <p:tag name="KSO_WM_UNIT_DIAGRAM_ISREFERUNIT" val="0"/>
+  <p:tag name="KSO_WM_UNIT_ID" val="_2**"/>
+  <p:tag name="KSO_WM_UNIT_LAYERLEVEL" val="1"/>
+  <p:tag name="KSO_WM_TAG_VERSION" val="1.0"/>
+  <p:tag name="KSO_WM_BEAUTIFY_FLAG" val="#wm#"/>
+</p:tagLst>
+</file>
+
+<file path=ppt/tags/tag173.xml><?xml version="1.0" encoding="utf-8"?>
+<p:tagLst xmlns:p="http://schemas.openxmlformats.org/presentationml/2006/main">
+  <p:tag name="KSO_WM_BEAUTIFY_FLAG" val="#wm#"/>
+  <p:tag name="KSO_WM_TEMPLATE_CATEGORY" val="custom"/>
+  <p:tag name="KSO_WM_TEMPLATE_INDEX" val="20205081"/>
+</p:tagLst>
+</file>
+
+<file path=ppt/tags/tag174.xml><?xml version="1.0" encoding="utf-8"?>
+<p:tagLst xmlns:p="http://schemas.openxmlformats.org/presentationml/2006/main">
+  <p:tag name="KSO_WM_UNIT_HIGHLIGHT" val="0"/>
+  <p:tag name="KSO_WM_UNIT_COMPATIBLE" val="0"/>
+  <p:tag name="KSO_WM_UNIT_DIAGRAM_ISNUMVISUAL" val="0"/>
+  <p:tag name="KSO_WM_UNIT_DIAGRAM_ISREFERUNIT" val="0"/>
+  <p:tag name="KSO_WM_UNIT_ID" val="_2**"/>
+  <p:tag name="KSO_WM_UNIT_LAYERLEVEL" val="1"/>
+  <p:tag name="KSO_WM_TAG_VERSION" val="1.0"/>
+  <p:tag name="KSO_WM_BEAUTIFY_FLAG" val="#wm#"/>
+</p:tagLst>
+</file>
+
+<file path=ppt/tags/tag175.xml><?xml version="1.0" encoding="utf-8"?>
+<p:tagLst xmlns:p="http://schemas.openxmlformats.org/presentationml/2006/main">
+  <p:tag name="KSO_WM_UNIT_HIGHLIGHT" val="0"/>
+  <p:tag name="KSO_WM_UNIT_COMPATIBLE" val="0"/>
+  <p:tag name="KSO_WM_UNIT_DIAGRAM_ISNUMVISUAL" val="0"/>
+  <p:tag name="KSO_WM_UNIT_DIAGRAM_ISREFERUNIT" val="0"/>
+  <p:tag name="KSO_WM_UNIT_ID" val="_2**"/>
+  <p:tag name="KSO_WM_UNIT_LAYERLEVEL" val="1"/>
+  <p:tag name="KSO_WM_TAG_VERSION" val="1.0"/>
+  <p:tag name="KSO_WM_BEAUTIFY_FLAG" val="#wm#"/>
+</p:tagLst>
+</file>
+
+<file path=ppt/tags/tag176.xml><?xml version="1.0" encoding="utf-8"?>
+<p:tagLst xmlns:p="http://schemas.openxmlformats.org/presentationml/2006/main">
+  <p:tag name="KSO_WM_BEAUTIFY_FLAG" val="#wm#"/>
+  <p:tag name="KSO_WM_TEMPLATE_CATEGORY" val="custom"/>
+  <p:tag name="KSO_WM_TEMPLATE_INDEX" val="20205081"/>
+</p:tagLst>
+</file>
+
+<file path=ppt/tags/tag177.xml><?xml version="1.0" encoding="utf-8"?>
+<p:tagLst xmlns:p="http://schemas.openxmlformats.org/presentationml/2006/main">
+  <p:tag name="KSO_WM_UNIT_HIGHLIGHT" val="0"/>
+  <p:tag name="KSO_WM_UNIT_COMPATIBLE" val="0"/>
+  <p:tag name="KSO_WM_UNIT_DIAGRAM_ISNUMVISUAL" val="0"/>
+  <p:tag name="KSO_WM_UNIT_DIAGRAM_ISREFERUNIT" val="0"/>
+  <p:tag name="KSO_WM_UNIT_ID" val="_2**"/>
+  <p:tag name="KSO_WM_UNIT_LAYERLEVEL" val="1"/>
+  <p:tag name="KSO_WM_TAG_VERSION" val="1.0"/>
+  <p:tag name="KSO_WM_BEAUTIFY_FLAG" val="#wm#"/>
+</p:tagLst>
+</file>
+
+<file path=ppt/tags/tag178.xml><?xml version="1.0" encoding="utf-8"?>
+<p:tagLst xmlns:p="http://schemas.openxmlformats.org/presentationml/2006/main">
+  <p:tag name="KSO_WM_UNIT_HIGHLIGHT" val="0"/>
+  <p:tag name="KSO_WM_UNIT_COMPATIBLE" val="0"/>
+  <p:tag name="KSO_WM_UNIT_DIAGRAM_ISNUMVISUAL" val="0"/>
+  <p:tag name="KSO_WM_UNIT_DIAGRAM_ISREFERUNIT" val="0"/>
+  <p:tag name="KSO_WM_UNIT_ID" val="_2**"/>
+  <p:tag name="KSO_WM_UNIT_LAYERLEVEL" val="1"/>
+  <p:tag name="KSO_WM_TAG_VERSION" val="1.0"/>
+  <p:tag name="KSO_WM_BEAUTIFY_FLAG" val="#wm#"/>
+</p:tagLst>
+</file>
+
+<file path=ppt/tags/tag179.xml><?xml version="1.0" encoding="utf-8"?>
+<p:tagLst xmlns:p="http://schemas.openxmlformats.org/presentationml/2006/main">
+  <p:tag name="KSO_WM_BEAUTIFY_FLAG" val="#wm#"/>
+  <p:tag name="KSO_WM_TEMPLATE_CATEGORY" val="custom"/>
+  <p:tag name="KSO_WM_TEMPLATE_INDEX" val="20205081"/>
 </p:tagLst>
 </file>
 

</xml_diff>